<commit_message>
feat: professional dizayn va mavzuga aloqador protsessual rasmlar
</commit_message>
<xml_diff>
--- a/fleshka_usb_taqdimot.pptx
+++ b/fleshka_usb_taqdimot.pptx
@@ -141,11 +141,38 @@
           <a:p/>
         </p:txBody>
       </p:sp>
+      <p:sp>
+        <p:nvSpPr>
+          <p:cNvPr id="12" name="imgpanel"/>
+          <p:cNvSpPr/>
+          <p:nvPr/>
+        </p:nvSpPr>
+        <p:spPr>
+          <a:xfrm>
+            <a:off x="6766560" y="0"/>
+            <a:ext cx="5425135" cy="6858000"/>
+          </a:xfrm>
+          <a:prstGeom prst="rect">
+            <a:avLst/>
+          </a:prstGeom>
+          <a:solidFill>
+            <a:srgbClr val="122A45"/>
+          </a:solidFill>
+          <a:ln>
+            <a:noFill/>
+          </a:ln>
+        </p:spPr>
+        <p:txBody>
+          <a:bodyPr/>
+          <a:lstStyle/>
+          <a:p/>
+        </p:txBody>
+      </p:sp>
       <p:pic>
         <p:nvPicPr>
-          <p:cNvPr id="12" name="img"/>
+          <p:cNvPr id="13" name="img"/>
           <p:cNvPicPr>
-            <a:picLocks noChangeAspect="0"/>
+            <a:picLocks noChangeAspect="1"/>
           </p:cNvPicPr>
           <p:nvPr/>
         </p:nvPicPr>
@@ -157,8 +184,8 @@
         </p:blipFill>
         <p:spPr>
           <a:xfrm>
-            <a:off x="6766560" y="0"/>
-            <a:ext cx="5425135" cy="6858000"/>
+            <a:off x="6766560" y="716432"/>
+            <a:ext cx="5425135" cy="5425135"/>
           </a:xfrm>
           <a:prstGeom prst="rect">
             <a:avLst/>
@@ -167,14 +194,14 @@
       </p:pic>
       <p:sp>
         <p:nvSpPr>
-          <p:cNvPr id="13" name="accent"/>
+          <p:cNvPr id="14" name="accent"/>
           <p:cNvSpPr/>
           <p:nvPr/>
         </p:nvSpPr>
         <p:spPr>
           <a:xfrm>
             <a:off x="548640" y="1097280"/>
-            <a:ext cx="109728" cy="2194560"/>
+            <a:ext cx="128016" cy="2103120"/>
           </a:xfrm>
           <a:prstGeom prst="rect">
             <a:avLst/>
@@ -194,13 +221,13 @@
       </p:sp>
       <p:sp>
         <p:nvSpPr>
-          <p:cNvPr id="14" name="title"/>
+          <p:cNvPr id="15" name="title"/>
           <p:cNvSpPr txBox="1"/>
           <p:nvPr/>
         </p:nvSpPr>
         <p:spPr>
           <a:xfrm>
-            <a:off x="822960" y="1005840"/>
+            <a:off x="868680" y="1005840"/>
             <a:ext cx="5577840" cy="2560320"/>
           </a:xfrm>
           <a:prstGeom prst="rect">
@@ -248,13 +275,40 @@
       </p:sp>
       <p:sp>
         <p:nvSpPr>
-          <p:cNvPr id="15" name="meta"/>
+          <p:cNvPr id="16" name="divider"/>
+          <p:cNvSpPr/>
+          <p:nvPr/>
+        </p:nvSpPr>
+        <p:spPr>
+          <a:xfrm>
+            <a:off x="868680" y="3794760"/>
+            <a:ext cx="5394960" cy="10972"/>
+          </a:xfrm>
+          <a:prstGeom prst="rect">
+            <a:avLst/>
+          </a:prstGeom>
+          <a:solidFill>
+            <a:srgbClr val="122A45"/>
+          </a:solidFill>
+          <a:ln>
+            <a:noFill/>
+          </a:ln>
+        </p:spPr>
+        <p:txBody>
+          <a:bodyPr/>
+          <a:lstStyle/>
+          <a:p/>
+        </p:txBody>
+      </p:sp>
+      <p:sp>
+        <p:nvSpPr>
+          <p:cNvPr id="17" name="meta"/>
           <p:cNvSpPr txBox="1"/>
           <p:nvPr/>
         </p:nvSpPr>
         <p:spPr>
           <a:xfrm>
-            <a:off x="822960" y="3931920"/>
+            <a:off x="868680" y="3977639"/>
             <a:ext cx="5577840" cy="2560320"/>
           </a:xfrm>
           <a:prstGeom prst="rect">
@@ -397,7 +451,7 @@
         <p:nvPicPr>
           <p:cNvPr id="12" name="img"/>
           <p:cNvPicPr>
-            <a:picLocks noChangeAspect="0"/>
+            <a:picLocks noChangeAspect="1"/>
           </p:cNvPicPr>
           <p:nvPr/>
         </p:nvPicPr>
@@ -409,8 +463,8 @@
         </p:blipFill>
         <p:spPr>
           <a:xfrm>
-            <a:off x="0" y="0"/>
-            <a:ext cx="12191695" cy="6858000"/>
+            <a:off x="2666847" y="0"/>
+            <a:ext cx="6858000" cy="6858000"/>
           </a:xfrm>
           <a:prstGeom prst="rect">
             <a:avLst/>
@@ -425,8 +479,8 @@
         </p:nvSpPr>
         <p:spPr>
           <a:xfrm>
-            <a:off x="1371600" y="2103120"/>
-            <a:ext cx="9445752" cy="2743200"/>
+            <a:off x="1371600" y="2011680"/>
+            <a:ext cx="9445752" cy="2834640"/>
           </a:xfrm>
           <a:prstGeom prst="rect">
             <a:avLst/>
@@ -448,14 +502,41 @@
       </p:sp>
       <p:sp>
         <p:nvSpPr>
-          <p:cNvPr id="14" name="ctext"/>
+          <p:cNvPr id="14" name="cbar"/>
+          <p:cNvSpPr/>
+          <p:nvPr/>
+        </p:nvSpPr>
+        <p:spPr>
+          <a:xfrm>
+            <a:off x="5641848" y="2331720"/>
+            <a:ext cx="914400" cy="54864"/>
+          </a:xfrm>
+          <a:prstGeom prst="rect">
+            <a:avLst/>
+          </a:prstGeom>
+          <a:solidFill>
+            <a:srgbClr val="00C2D1"/>
+          </a:solidFill>
+          <a:ln>
+            <a:noFill/>
+          </a:ln>
+        </p:spPr>
+        <p:txBody>
+          <a:bodyPr/>
+          <a:lstStyle/>
+          <a:p/>
+        </p:txBody>
+      </p:sp>
+      <p:sp>
+        <p:nvSpPr>
+          <p:cNvPr id="15" name="ctext"/>
           <p:cNvSpPr txBox="1"/>
           <p:nvPr/>
         </p:nvSpPr>
         <p:spPr>
           <a:xfrm>
-            <a:off x="1645920" y="2286000"/>
-            <a:ext cx="8869680" cy="2377440"/>
+            <a:off x="1737360" y="2194560"/>
+            <a:ext cx="8714232" cy="2468880"/>
           </a:xfrm>
           <a:prstGeom prst="rect">
             <a:avLst/>
@@ -468,7 +549,11 @@
           </a:bodyPr>
           <a:lstStyle/>
           <a:p>
-            <a:pPr algn="ctr"/>
+            <a:pPr algn="ctr">
+              <a:spcBef>
+                <a:spcPts val="600"/>
+              </a:spcBef>
+            </a:pPr>
             <a:r>
               <a:rPr lang="uz-UZ" sz="4000" b="1" dirty="0">
                 <a:solidFill>
@@ -591,14 +676,14 @@
       </p:sp>
       <p:sp>
         <p:nvSpPr>
-          <p:cNvPr id="12" name="topbar"/>
-          <p:cNvSpPr/>
-          <p:nvPr/>
-        </p:nvSpPr>
-        <p:spPr>
-          <a:xfrm>
-            <a:off x="0" y="1051560"/>
-            <a:ext cx="12191695" cy="45720"/>
+          <p:cNvPr id="12" name="tbar"/>
+          <p:cNvSpPr/>
+          <p:nvPr/>
+        </p:nvSpPr>
+        <p:spPr>
+          <a:xfrm>
+            <a:off x="548640" y="301752"/>
+            <a:ext cx="128016" cy="566928"/>
           </a:xfrm>
           <a:prstGeom prst="rect">
             <a:avLst/>
@@ -618,41 +703,14 @@
       </p:sp>
       <p:sp>
         <p:nvSpPr>
-          <p:cNvPr id="13" name="tbar"/>
-          <p:cNvSpPr/>
-          <p:nvPr/>
-        </p:nvSpPr>
-        <p:spPr>
-          <a:xfrm>
-            <a:off x="548640" y="320040"/>
-            <a:ext cx="109728" cy="548640"/>
-          </a:xfrm>
-          <a:prstGeom prst="rect">
-            <a:avLst/>
-          </a:prstGeom>
-          <a:solidFill>
-            <a:srgbClr val="00C2D1"/>
-          </a:solidFill>
-          <a:ln>
-            <a:noFill/>
-          </a:ln>
-        </p:spPr>
-        <p:txBody>
-          <a:bodyPr/>
-          <a:lstStyle/>
-          <a:p/>
-        </p:txBody>
-      </p:sp>
-      <p:sp>
-        <p:nvSpPr>
-          <p:cNvPr id="14" name="title"/>
+          <p:cNvPr id="13" name="title"/>
           <p:cNvSpPr txBox="1"/>
           <p:nvPr/>
         </p:nvSpPr>
         <p:spPr>
           <a:xfrm>
-            <a:off x="822960" y="274320"/>
-            <a:ext cx="10789920" cy="822960"/>
+            <a:off x="868680" y="256032"/>
+            <a:ext cx="10789920" cy="713232"/>
           </a:xfrm>
           <a:prstGeom prst="rect">
             <a:avLst/>
@@ -679,11 +737,67 @@
           </a:p>
         </p:txBody>
       </p:sp>
+      <p:sp>
+        <p:nvSpPr>
+          <p:cNvPr id="14" name="topbar"/>
+          <p:cNvSpPr/>
+          <p:nvPr/>
+        </p:nvSpPr>
+        <p:spPr>
+          <a:xfrm>
+            <a:off x="548640" y="1024128"/>
+            <a:ext cx="11091672" cy="36576"/>
+          </a:xfrm>
+          <a:prstGeom prst="rect">
+            <a:avLst/>
+          </a:prstGeom>
+          <a:solidFill>
+            <a:srgbClr val="00C2D1"/>
+          </a:solidFill>
+          <a:ln>
+            <a:noFill/>
+          </a:ln>
+        </p:spPr>
+        <p:txBody>
+          <a:bodyPr/>
+          <a:lstStyle/>
+          <a:p/>
+        </p:txBody>
+      </p:sp>
+      <p:sp>
+        <p:nvSpPr>
+          <p:cNvPr id="15" name="imgpanel"/>
+          <p:cNvSpPr/>
+          <p:nvPr/>
+        </p:nvSpPr>
+        <p:spPr>
+          <a:xfrm>
+            <a:off x="7635240" y="1325880"/>
+            <a:ext cx="4005072" cy="4892040"/>
+          </a:xfrm>
+          <a:prstGeom prst="rect">
+            <a:avLst/>
+          </a:prstGeom>
+          <a:solidFill>
+            <a:srgbClr val="122A45"/>
+          </a:solidFill>
+          <a:ln w="12700">
+            <a:solidFill>
+              <a:srgbClr val="3B82F6"/>
+            </a:solidFill>
+          </a:ln>
+        </p:spPr>
+        <p:txBody>
+          <a:bodyPr/>
+          <a:lstStyle/>
+          <a:p/>
+        </p:txBody>
+      </p:sp>
       <p:pic>
         <p:nvPicPr>
-          <p:cNvPr id="15" name="img"/>
+          <p:cNvPr id="16" name="img"/>
           <p:cNvPicPr>
-            <a:picLocks noChangeAspect="0"/>
+            <a:picLocks noChangeAspect="1"/>
           </p:cNvPicPr>
           <p:nvPr/>
         </p:nvPicPr>
@@ -695,8 +809,8 @@
         </p:blipFill>
         <p:spPr>
           <a:xfrm>
-            <a:off x="7772400" y="1463040"/>
-            <a:ext cx="3931920" cy="4937760"/>
+            <a:off x="7799832" y="1933956"/>
+            <a:ext cx="3675888" cy="3675888"/>
           </a:xfrm>
           <a:prstGeom prst="rect">
             <a:avLst/>
@@ -705,14 +819,14 @@
       </p:pic>
       <p:sp>
         <p:nvSpPr>
-          <p:cNvPr id="16" name="panel"/>
-          <p:cNvSpPr/>
-          <p:nvPr/>
-        </p:nvSpPr>
-        <p:spPr>
-          <a:xfrm>
-            <a:off x="457200" y="1463040"/>
-            <a:ext cx="7040880" cy="4937760"/>
+          <p:cNvPr id="17" name="panel"/>
+          <p:cNvSpPr/>
+          <p:nvPr/>
+        </p:nvSpPr>
+        <p:spPr>
+          <a:xfrm>
+            <a:off x="457200" y="1325880"/>
+            <a:ext cx="6858000" cy="4892040"/>
           </a:xfrm>
           <a:prstGeom prst="rect">
             <a:avLst/>
@@ -732,14 +846,41 @@
       </p:sp>
       <p:sp>
         <p:nvSpPr>
-          <p:cNvPr id="17" name="body"/>
+          <p:cNvPr id="18" name="panelbar"/>
+          <p:cNvSpPr/>
+          <p:nvPr/>
+        </p:nvSpPr>
+        <p:spPr>
+          <a:xfrm>
+            <a:off x="457200" y="1325880"/>
+            <a:ext cx="73152" cy="4892040"/>
+          </a:xfrm>
+          <a:prstGeom prst="rect">
+            <a:avLst/>
+          </a:prstGeom>
+          <a:solidFill>
+            <a:srgbClr val="00C2D1"/>
+          </a:solidFill>
+          <a:ln>
+            <a:noFill/>
+          </a:ln>
+        </p:spPr>
+        <p:txBody>
+          <a:bodyPr/>
+          <a:lstStyle/>
+          <a:p/>
+        </p:txBody>
+      </p:sp>
+      <p:sp>
+        <p:nvSpPr>
+          <p:cNvPr id="19" name="body"/>
           <p:cNvSpPr txBox="1"/>
           <p:nvPr/>
         </p:nvSpPr>
         <p:spPr>
           <a:xfrm>
-            <a:off x="731520" y="1691640"/>
-            <a:ext cx="6492240" cy="4480560"/>
+            <a:off x="868680" y="1600200"/>
+            <a:ext cx="6126480" cy="4572000"/>
           </a:xfrm>
           <a:prstGeom prst="rect">
             <a:avLst/>
@@ -753,8 +894,11 @@
           <a:lstStyle/>
           <a:p>
             <a:pPr>
+              <a:spcBef>
+                <a:spcPts val="600"/>
+              </a:spcBef>
               <a:spcAft>
-                <a:spcPts val="1000"/>
+                <a:spcPts val="800"/>
               </a:spcAft>
             </a:pPr>
             <a:r>
@@ -771,8 +915,11 @@
           </a:p>
           <a:p>
             <a:pPr>
+              <a:spcBef>
+                <a:spcPts val="600"/>
+              </a:spcBef>
               <a:spcAft>
-                <a:spcPts val="1000"/>
+                <a:spcPts val="800"/>
               </a:spcAft>
             </a:pPr>
             <a:r>
@@ -789,8 +936,11 @@
           </a:p>
           <a:p>
             <a:pPr>
+              <a:spcBef>
+                <a:spcPts val="600"/>
+              </a:spcBef>
               <a:spcAft>
-                <a:spcPts val="1000"/>
+                <a:spcPts val="800"/>
               </a:spcAft>
             </a:pPr>
             <a:r>
@@ -807,8 +957,11 @@
           </a:p>
           <a:p>
             <a:pPr>
+              <a:spcBef>
+                <a:spcPts val="600"/>
+              </a:spcBef>
               <a:spcAft>
-                <a:spcPts val="1000"/>
+                <a:spcPts val="800"/>
               </a:spcAft>
             </a:pPr>
             <a:r>
@@ -821,6 +974,106 @@
                 <a:ea typeface="Times New Roman"/>
               </a:rPr>
               <a:t>Xulosa. Flesh xotiralarning zamonaviy axborot tizimlaridagi ahamiyati.</a:t>
+            </a:r>
+          </a:p>
+        </p:txBody>
+      </p:sp>
+      <p:sp>
+        <p:nvSpPr>
+          <p:cNvPr id="20" name="footline"/>
+          <p:cNvSpPr/>
+          <p:nvPr/>
+        </p:nvSpPr>
+        <p:spPr>
+          <a:xfrm>
+            <a:off x="548640" y="6419088"/>
+            <a:ext cx="11091672" cy="10972"/>
+          </a:xfrm>
+          <a:prstGeom prst="rect">
+            <a:avLst/>
+          </a:prstGeom>
+          <a:solidFill>
+            <a:srgbClr val="122A45"/>
+          </a:solidFill>
+          <a:ln>
+            <a:noFill/>
+          </a:ln>
+        </p:spPr>
+        <p:txBody>
+          <a:bodyPr/>
+          <a:lstStyle/>
+          <a:p/>
+        </p:txBody>
+      </p:sp>
+      <p:sp>
+        <p:nvSpPr>
+          <p:cNvPr id="21" name="foot_l"/>
+          <p:cNvSpPr txBox="1"/>
+          <p:nvPr/>
+        </p:nvSpPr>
+        <p:spPr>
+          <a:xfrm>
+            <a:off x="548640" y="6455664"/>
+            <a:ext cx="8229600" cy="365760"/>
+          </a:xfrm>
+          <a:prstGeom prst="rect">
+            <a:avLst/>
+          </a:prstGeom>
+          <a:noFill/>
+        </p:spPr>
+        <p:txBody>
+          <a:bodyPr wrap="square" anchor="ctr">
+            <a:normAutofit/>
+          </a:bodyPr>
+          <a:lstStyle/>
+          <a:p>
+            <a:r>
+              <a:rPr lang="uz-UZ" sz="1400" dirty="0">
+                <a:solidFill>
+                  <a:srgbClr val="E2E8F0"/>
+                </a:solidFill>
+                <a:latin typeface="Times New Roman"/>
+                <a:cs typeface="Times New Roman"/>
+                <a:ea typeface="Times New Roman"/>
+              </a:rPr>
+              <a:t>Fleshkalar (USB) qanday ishlaydi?</a:t>
+            </a:r>
+          </a:p>
+        </p:txBody>
+      </p:sp>
+      <p:sp>
+        <p:nvSpPr>
+          <p:cNvPr id="22" name="foot_r"/>
+          <p:cNvSpPr txBox="1"/>
+          <p:nvPr/>
+        </p:nvSpPr>
+        <p:spPr>
+          <a:xfrm>
+            <a:off x="8961120" y="6455664"/>
+            <a:ext cx="2679192" cy="365760"/>
+          </a:xfrm>
+          <a:prstGeom prst="rect">
+            <a:avLst/>
+          </a:prstGeom>
+          <a:noFill/>
+        </p:spPr>
+        <p:txBody>
+          <a:bodyPr wrap="square" anchor="ctr">
+            <a:normAutofit/>
+          </a:bodyPr>
+          <a:lstStyle/>
+          <a:p>
+            <a:pPr algn="r"/>
+            <a:r>
+              <a:rPr lang="uz-UZ" sz="1400" b="1" dirty="0">
+                <a:solidFill>
+                  <a:srgbClr val="00C2D1"/>
+                </a:solidFill>
+                <a:latin typeface="Times New Roman"/>
+                <a:cs typeface="Times New Roman"/>
+                <a:ea typeface="Times New Roman"/>
+              </a:rPr>
+              <a:t>2 / 10</a:t>
             </a:r>
           </a:p>
         </p:txBody>
@@ -879,14 +1132,14 @@
       </p:sp>
       <p:sp>
         <p:nvSpPr>
-          <p:cNvPr id="12" name="topbar"/>
-          <p:cNvSpPr/>
-          <p:nvPr/>
-        </p:nvSpPr>
-        <p:spPr>
-          <a:xfrm>
-            <a:off x="0" y="1051560"/>
-            <a:ext cx="12191695" cy="45720"/>
+          <p:cNvPr id="12" name="tbar"/>
+          <p:cNvSpPr/>
+          <p:nvPr/>
+        </p:nvSpPr>
+        <p:spPr>
+          <a:xfrm>
+            <a:off x="548640" y="301752"/>
+            <a:ext cx="128016" cy="566928"/>
           </a:xfrm>
           <a:prstGeom prst="rect">
             <a:avLst/>
@@ -906,41 +1159,14 @@
       </p:sp>
       <p:sp>
         <p:nvSpPr>
-          <p:cNvPr id="13" name="tbar"/>
-          <p:cNvSpPr/>
-          <p:nvPr/>
-        </p:nvSpPr>
-        <p:spPr>
-          <a:xfrm>
-            <a:off x="548640" y="320040"/>
-            <a:ext cx="109728" cy="548640"/>
-          </a:xfrm>
-          <a:prstGeom prst="rect">
-            <a:avLst/>
-          </a:prstGeom>
-          <a:solidFill>
-            <a:srgbClr val="00C2D1"/>
-          </a:solidFill>
-          <a:ln>
-            <a:noFill/>
-          </a:ln>
-        </p:spPr>
-        <p:txBody>
-          <a:bodyPr/>
-          <a:lstStyle/>
-          <a:p/>
-        </p:txBody>
-      </p:sp>
-      <p:sp>
-        <p:nvSpPr>
-          <p:cNvPr id="14" name="title"/>
+          <p:cNvPr id="13" name="title"/>
           <p:cNvSpPr txBox="1"/>
           <p:nvPr/>
         </p:nvSpPr>
         <p:spPr>
           <a:xfrm>
-            <a:off x="822960" y="274320"/>
-            <a:ext cx="10789920" cy="822960"/>
+            <a:off x="868680" y="256032"/>
+            <a:ext cx="10789920" cy="713232"/>
           </a:xfrm>
           <a:prstGeom prst="rect">
             <a:avLst/>
@@ -967,11 +1193,67 @@
           </a:p>
         </p:txBody>
       </p:sp>
+      <p:sp>
+        <p:nvSpPr>
+          <p:cNvPr id="14" name="topbar"/>
+          <p:cNvSpPr/>
+          <p:nvPr/>
+        </p:nvSpPr>
+        <p:spPr>
+          <a:xfrm>
+            <a:off x="548640" y="1024128"/>
+            <a:ext cx="11091672" cy="36576"/>
+          </a:xfrm>
+          <a:prstGeom prst="rect">
+            <a:avLst/>
+          </a:prstGeom>
+          <a:solidFill>
+            <a:srgbClr val="00C2D1"/>
+          </a:solidFill>
+          <a:ln>
+            <a:noFill/>
+          </a:ln>
+        </p:spPr>
+        <p:txBody>
+          <a:bodyPr/>
+          <a:lstStyle/>
+          <a:p/>
+        </p:txBody>
+      </p:sp>
+      <p:sp>
+        <p:nvSpPr>
+          <p:cNvPr id="15" name="imgpanel"/>
+          <p:cNvSpPr/>
+          <p:nvPr/>
+        </p:nvSpPr>
+        <p:spPr>
+          <a:xfrm>
+            <a:off x="7635240" y="1325880"/>
+            <a:ext cx="4005072" cy="4892040"/>
+          </a:xfrm>
+          <a:prstGeom prst="rect">
+            <a:avLst/>
+          </a:prstGeom>
+          <a:solidFill>
+            <a:srgbClr val="122A45"/>
+          </a:solidFill>
+          <a:ln w="12700">
+            <a:solidFill>
+              <a:srgbClr val="3B82F6"/>
+            </a:solidFill>
+          </a:ln>
+        </p:spPr>
+        <p:txBody>
+          <a:bodyPr/>
+          <a:lstStyle/>
+          <a:p/>
+        </p:txBody>
+      </p:sp>
       <p:pic>
         <p:nvPicPr>
-          <p:cNvPr id="15" name="img"/>
+          <p:cNvPr id="16" name="img"/>
           <p:cNvPicPr>
-            <a:picLocks noChangeAspect="0"/>
+            <a:picLocks noChangeAspect="1"/>
           </p:cNvPicPr>
           <p:nvPr/>
         </p:nvPicPr>
@@ -983,8 +1265,8 @@
         </p:blipFill>
         <p:spPr>
           <a:xfrm>
-            <a:off x="7772400" y="1463040"/>
-            <a:ext cx="3931920" cy="4937760"/>
+            <a:off x="7799832" y="1933956"/>
+            <a:ext cx="3675888" cy="3675888"/>
           </a:xfrm>
           <a:prstGeom prst="rect">
             <a:avLst/>
@@ -993,14 +1275,14 @@
       </p:pic>
       <p:sp>
         <p:nvSpPr>
-          <p:cNvPr id="16" name="panel"/>
-          <p:cNvSpPr/>
-          <p:nvPr/>
-        </p:nvSpPr>
-        <p:spPr>
-          <a:xfrm>
-            <a:off x="457200" y="1463040"/>
-            <a:ext cx="7040880" cy="4937760"/>
+          <p:cNvPr id="17" name="panel"/>
+          <p:cNvSpPr/>
+          <p:nvPr/>
+        </p:nvSpPr>
+        <p:spPr>
+          <a:xfrm>
+            <a:off x="457200" y="1325880"/>
+            <a:ext cx="6858000" cy="4892040"/>
           </a:xfrm>
           <a:prstGeom prst="rect">
             <a:avLst/>
@@ -1020,14 +1302,41 @@
       </p:sp>
       <p:sp>
         <p:nvSpPr>
-          <p:cNvPr id="17" name="body"/>
+          <p:cNvPr id="18" name="panelbar"/>
+          <p:cNvSpPr/>
+          <p:nvPr/>
+        </p:nvSpPr>
+        <p:spPr>
+          <a:xfrm>
+            <a:off x="457200" y="1325880"/>
+            <a:ext cx="73152" cy="4892040"/>
+          </a:xfrm>
+          <a:prstGeom prst="rect">
+            <a:avLst/>
+          </a:prstGeom>
+          <a:solidFill>
+            <a:srgbClr val="00C2D1"/>
+          </a:solidFill>
+          <a:ln>
+            <a:noFill/>
+          </a:ln>
+        </p:spPr>
+        <p:txBody>
+          <a:bodyPr/>
+          <a:lstStyle/>
+          <a:p/>
+        </p:txBody>
+      </p:sp>
+      <p:sp>
+        <p:nvSpPr>
+          <p:cNvPr id="19" name="body"/>
           <p:cNvSpPr txBox="1"/>
           <p:nvPr/>
         </p:nvSpPr>
         <p:spPr>
           <a:xfrm>
-            <a:off x="731520" y="1691640"/>
-            <a:ext cx="6492240" cy="4480560"/>
+            <a:off x="868680" y="1600200"/>
+            <a:ext cx="6126480" cy="4572000"/>
           </a:xfrm>
           <a:prstGeom prst="rect">
             <a:avLst/>
@@ -1041,11 +1350,77 @@
           <a:lstStyle/>
           <a:p>
             <a:pPr>
+              <a:spcBef>
+                <a:spcPts val="600"/>
+              </a:spcBef>
+              <a:spcAft>
+                <a:spcPts val="800"/>
+              </a:spcAft>
+            </a:pPr>
+            <a:r>
+              <a:rPr lang="uz-UZ" sz="1800" b="1" dirty="0">
+                <a:solidFill>
+                  <a:srgbClr val="00C2D1"/>
+                </a:solidFill>
+                <a:latin typeface="Times New Roman"/>
+                <a:cs typeface="Times New Roman"/>
+                <a:ea typeface="Times New Roman"/>
+              </a:rPr>
+              <a:t>Fleshkalar (USB) va SSD disklar qattiq disklar (HDD) kabi aylanuvchi magnit plastinalarga ega emas. Ularning ichida mutlaqo harakatlanuvchi qismlar yo'q.</a:t>
+            </a:r>
+          </a:p>
+          <a:p>
+            <a:pPr>
+              <a:spcBef>
+                <a:spcPts val="600"/>
+              </a:spcBef>
+              <a:spcAft>
+                <a:spcPts val="800"/>
+              </a:spcAft>
+            </a:pPr>
+            <a:r>
+              <a:rPr lang="uz-UZ" sz="1800" b="1" dirty="0">
+                <a:solidFill>
+                  <a:srgbClr val="00C2D1"/>
+                </a:solidFill>
+                <a:latin typeface="Times New Roman"/>
+                <a:cs typeface="Times New Roman"/>
+                <a:ea typeface="Times New Roman"/>
+              </a:rPr>
+              <a:t>Solid-State:</a:t>
+            </a:r>
+          </a:p>
+          <a:p>
+            <a:pPr marL="256032" indent="0">
+              <a:spcBef>
+                <a:spcPts val="400"/>
+              </a:spcBef>
               <a:spcAft>
                 <a:spcPts val="1000"/>
               </a:spcAft>
             </a:pPr>
             <a:r>
+              <a:rPr lang="uz-UZ" sz="1600" dirty="0">
+                <a:solidFill>
+                  <a:srgbClr val="E2E8F0"/>
+                </a:solidFill>
+                <a:latin typeface="Times New Roman"/>
+                <a:cs typeface="Times New Roman"/>
+                <a:ea typeface="Times New Roman"/>
+              </a:rPr>
+              <a:t>- Axborot faqatgina elektr toklari yordamida qattiq jismli (Solid-State) mikrosxemalarda saqlanadi.</a:t>
+            </a:r>
+          </a:p>
+          <a:p>
+            <a:pPr>
+              <a:spcBef>
+                <a:spcPts val="600"/>
+              </a:spcBef>
+              <a:spcAft>
+                <a:spcPts val="800"/>
+              </a:spcAft>
+            </a:pPr>
+            <a:r>
               <a:rPr lang="uz-UZ" sz="1800" b="1" dirty="0">
                 <a:solidFill>
                   <a:srgbClr val="00C2D1"/>
@@ -1054,17 +1429,120 @@
                 <a:cs typeface="Times New Roman"/>
                 <a:ea typeface="Times New Roman"/>
               </a:rPr>
-              <a:t>Fleshkalar (USB) va SSD disklar qattiq disklar (HDD) kabi aylanuvchi magnit plastinalarga ega emas. Ularning ichida mutlaqo harakatlanuvchi qismlar yo'q.</a:t>
-            </a:r>
-          </a:p>
-          <a:p>
-            <a:pPr>
+              <a:t>NAND darvozalari:</a:t>
+            </a:r>
+          </a:p>
+          <a:p>
+            <a:pPr marL="256032" indent="0">
+              <a:spcBef>
+                <a:spcPts val="400"/>
+              </a:spcBef>
               <a:spcAft>
                 <a:spcPts val="1000"/>
               </a:spcAft>
             </a:pPr>
             <a:r>
-              <a:rPr lang="uz-UZ" sz="1800" b="1" dirty="0">
+              <a:rPr lang="uz-UZ" sz="1600" dirty="0">
+                <a:solidFill>
+                  <a:srgbClr val="E2E8F0"/>
+                </a:solidFill>
+                <a:latin typeface="Times New Roman"/>
+                <a:cs typeface="Times New Roman"/>
+                <a:ea typeface="Times New Roman"/>
+              </a:rPr>
+              <a:t>- Fleshkaning ichidagi asosiy xotira chipi "NAND" deb ataluvchi milliardlab mitti tranzistorlardan tashkil topgan bo'lib, ular barcha ma'lumotlarni 0 va 1 ko'rinishida saqlaydi.</a:t>
+            </a:r>
+          </a:p>
+        </p:txBody>
+      </p:sp>
+      <p:sp>
+        <p:nvSpPr>
+          <p:cNvPr id="20" name="footline"/>
+          <p:cNvSpPr/>
+          <p:nvPr/>
+        </p:nvSpPr>
+        <p:spPr>
+          <a:xfrm>
+            <a:off x="548640" y="6419088"/>
+            <a:ext cx="11091672" cy="10972"/>
+          </a:xfrm>
+          <a:prstGeom prst="rect">
+            <a:avLst/>
+          </a:prstGeom>
+          <a:solidFill>
+            <a:srgbClr val="122A45"/>
+          </a:solidFill>
+          <a:ln>
+            <a:noFill/>
+          </a:ln>
+        </p:spPr>
+        <p:txBody>
+          <a:bodyPr/>
+          <a:lstStyle/>
+          <a:p/>
+        </p:txBody>
+      </p:sp>
+      <p:sp>
+        <p:nvSpPr>
+          <p:cNvPr id="21" name="foot_l"/>
+          <p:cNvSpPr txBox="1"/>
+          <p:nvPr/>
+        </p:nvSpPr>
+        <p:spPr>
+          <a:xfrm>
+            <a:off x="548640" y="6455664"/>
+            <a:ext cx="8229600" cy="365760"/>
+          </a:xfrm>
+          <a:prstGeom prst="rect">
+            <a:avLst/>
+          </a:prstGeom>
+          <a:noFill/>
+        </p:spPr>
+        <p:txBody>
+          <a:bodyPr wrap="square" anchor="ctr">
+            <a:normAutofit/>
+          </a:bodyPr>
+          <a:lstStyle/>
+          <a:p>
+            <a:r>
+              <a:rPr lang="uz-UZ" sz="1400" dirty="0">
+                <a:solidFill>
+                  <a:srgbClr val="E2E8F0"/>
+                </a:solidFill>
+                <a:latin typeface="Times New Roman"/>
+                <a:cs typeface="Times New Roman"/>
+                <a:ea typeface="Times New Roman"/>
+              </a:rPr>
+              <a:t>Fleshkalar (USB) qanday ishlaydi?</a:t>
+            </a:r>
+          </a:p>
+        </p:txBody>
+      </p:sp>
+      <p:sp>
+        <p:nvSpPr>
+          <p:cNvPr id="22" name="foot_r"/>
+          <p:cNvSpPr txBox="1"/>
+          <p:nvPr/>
+        </p:nvSpPr>
+        <p:spPr>
+          <a:xfrm>
+            <a:off x="8961120" y="6455664"/>
+            <a:ext cx="2679192" cy="365760"/>
+          </a:xfrm>
+          <a:prstGeom prst="rect">
+            <a:avLst/>
+          </a:prstGeom>
+          <a:noFill/>
+        </p:spPr>
+        <p:txBody>
+          <a:bodyPr wrap="square" anchor="ctr">
+            <a:normAutofit/>
+          </a:bodyPr>
+          <a:lstStyle/>
+          <a:p>
+            <a:pPr algn="r"/>
+            <a:r>
+              <a:rPr lang="uz-UZ" sz="1400" b="1" dirty="0">
                 <a:solidFill>
                   <a:srgbClr val="00C2D1"/>
                 </a:solidFill>
@@ -1072,61 +1550,7 @@
                 <a:cs typeface="Times New Roman"/>
                 <a:ea typeface="Times New Roman"/>
               </a:rPr>
-              <a:t>Solid-State:</a:t>
-            </a:r>
-          </a:p>
-          <a:p>
-            <a:pPr>
-              <a:spcAft>
-                <a:spcPts val="1000"/>
-              </a:spcAft>
-            </a:pPr>
-            <a:r>
-              <a:rPr lang="uz-UZ" sz="1600" dirty="0">
-                <a:solidFill>
-                  <a:srgbClr val="E2E8F0"/>
-                </a:solidFill>
-                <a:latin typeface="Times New Roman"/>
-                <a:cs typeface="Times New Roman"/>
-                <a:ea typeface="Times New Roman"/>
-              </a:rPr>
-              <a:t>- Axborot faqatgina elektr toklari yordamida qattiq jismli (Solid-State) mikrosxemalarda saqlanadi.</a:t>
-            </a:r>
-          </a:p>
-          <a:p>
-            <a:pPr>
-              <a:spcAft>
-                <a:spcPts val="1000"/>
-              </a:spcAft>
-            </a:pPr>
-            <a:r>
-              <a:rPr lang="uz-UZ" sz="1800" b="1" dirty="0">
-                <a:solidFill>
-                  <a:srgbClr val="00C2D1"/>
-                </a:solidFill>
-                <a:latin typeface="Times New Roman"/>
-                <a:cs typeface="Times New Roman"/>
-                <a:ea typeface="Times New Roman"/>
-              </a:rPr>
-              <a:t>NAND darvozalari:</a:t>
-            </a:r>
-          </a:p>
-          <a:p>
-            <a:pPr>
-              <a:spcAft>
-                <a:spcPts val="1000"/>
-              </a:spcAft>
-            </a:pPr>
-            <a:r>
-              <a:rPr lang="uz-UZ" sz="1600" dirty="0">
-                <a:solidFill>
-                  <a:srgbClr val="E2E8F0"/>
-                </a:solidFill>
-                <a:latin typeface="Times New Roman"/>
-                <a:cs typeface="Times New Roman"/>
-                <a:ea typeface="Times New Roman"/>
-              </a:rPr>
-              <a:t>- Fleshkaning ichidagi asosiy xotira chipi "NAND" deb ataluvchi milliardlab mitti tranzistorlardan tashkil topgan bo'lib, ular barcha ma'lumotlarni 0 va 1 ko'rinishida saqlaydi.</a:t>
+              <a:t>3 / 10</a:t>
             </a:r>
           </a:p>
         </p:txBody>
@@ -1185,14 +1609,14 @@
       </p:sp>
       <p:sp>
         <p:nvSpPr>
-          <p:cNvPr id="12" name="topbar"/>
-          <p:cNvSpPr/>
-          <p:nvPr/>
-        </p:nvSpPr>
-        <p:spPr>
-          <a:xfrm>
-            <a:off x="0" y="1051560"/>
-            <a:ext cx="12191695" cy="45720"/>
+          <p:cNvPr id="12" name="tbar"/>
+          <p:cNvSpPr/>
+          <p:nvPr/>
+        </p:nvSpPr>
+        <p:spPr>
+          <a:xfrm>
+            <a:off x="548640" y="301752"/>
+            <a:ext cx="128016" cy="566928"/>
           </a:xfrm>
           <a:prstGeom prst="rect">
             <a:avLst/>
@@ -1212,41 +1636,14 @@
       </p:sp>
       <p:sp>
         <p:nvSpPr>
-          <p:cNvPr id="13" name="tbar"/>
-          <p:cNvSpPr/>
-          <p:nvPr/>
-        </p:nvSpPr>
-        <p:spPr>
-          <a:xfrm>
-            <a:off x="548640" y="320040"/>
-            <a:ext cx="109728" cy="548640"/>
-          </a:xfrm>
-          <a:prstGeom prst="rect">
-            <a:avLst/>
-          </a:prstGeom>
-          <a:solidFill>
-            <a:srgbClr val="00C2D1"/>
-          </a:solidFill>
-          <a:ln>
-            <a:noFill/>
-          </a:ln>
-        </p:spPr>
-        <p:txBody>
-          <a:bodyPr/>
-          <a:lstStyle/>
-          <a:p/>
-        </p:txBody>
-      </p:sp>
-      <p:sp>
-        <p:nvSpPr>
-          <p:cNvPr id="14" name="title"/>
+          <p:cNvPr id="13" name="title"/>
           <p:cNvSpPr txBox="1"/>
           <p:nvPr/>
         </p:nvSpPr>
         <p:spPr>
           <a:xfrm>
-            <a:off x="822960" y="274320"/>
-            <a:ext cx="10789920" cy="822960"/>
+            <a:off x="868680" y="256032"/>
+            <a:ext cx="10789920" cy="713232"/>
           </a:xfrm>
           <a:prstGeom prst="rect">
             <a:avLst/>
@@ -1273,11 +1670,67 @@
           </a:p>
         </p:txBody>
       </p:sp>
+      <p:sp>
+        <p:nvSpPr>
+          <p:cNvPr id="14" name="topbar"/>
+          <p:cNvSpPr/>
+          <p:nvPr/>
+        </p:nvSpPr>
+        <p:spPr>
+          <a:xfrm>
+            <a:off x="548640" y="1024128"/>
+            <a:ext cx="11091672" cy="36576"/>
+          </a:xfrm>
+          <a:prstGeom prst="rect">
+            <a:avLst/>
+          </a:prstGeom>
+          <a:solidFill>
+            <a:srgbClr val="00C2D1"/>
+          </a:solidFill>
+          <a:ln>
+            <a:noFill/>
+          </a:ln>
+        </p:spPr>
+        <p:txBody>
+          <a:bodyPr/>
+          <a:lstStyle/>
+          <a:p/>
+        </p:txBody>
+      </p:sp>
+      <p:sp>
+        <p:nvSpPr>
+          <p:cNvPr id="15" name="imgpanel"/>
+          <p:cNvSpPr/>
+          <p:nvPr/>
+        </p:nvSpPr>
+        <p:spPr>
+          <a:xfrm>
+            <a:off x="7635240" y="1325880"/>
+            <a:ext cx="4005072" cy="4892040"/>
+          </a:xfrm>
+          <a:prstGeom prst="rect">
+            <a:avLst/>
+          </a:prstGeom>
+          <a:solidFill>
+            <a:srgbClr val="122A45"/>
+          </a:solidFill>
+          <a:ln w="12700">
+            <a:solidFill>
+              <a:srgbClr val="3B82F6"/>
+            </a:solidFill>
+          </a:ln>
+        </p:spPr>
+        <p:txBody>
+          <a:bodyPr/>
+          <a:lstStyle/>
+          <a:p/>
+        </p:txBody>
+      </p:sp>
       <p:pic>
         <p:nvPicPr>
-          <p:cNvPr id="15" name="img"/>
+          <p:cNvPr id="16" name="img"/>
           <p:cNvPicPr>
-            <a:picLocks noChangeAspect="0"/>
+            <a:picLocks noChangeAspect="1"/>
           </p:cNvPicPr>
           <p:nvPr/>
         </p:nvPicPr>
@@ -1289,8 +1742,8 @@
         </p:blipFill>
         <p:spPr>
           <a:xfrm>
-            <a:off x="7772400" y="1463040"/>
-            <a:ext cx="3931920" cy="4937760"/>
+            <a:off x="7799832" y="1933956"/>
+            <a:ext cx="3675888" cy="3675888"/>
           </a:xfrm>
           <a:prstGeom prst="rect">
             <a:avLst/>
@@ -1299,14 +1752,14 @@
       </p:pic>
       <p:sp>
         <p:nvSpPr>
-          <p:cNvPr id="16" name="panel"/>
-          <p:cNvSpPr/>
-          <p:nvPr/>
-        </p:nvSpPr>
-        <p:spPr>
-          <a:xfrm>
-            <a:off x="457200" y="1463040"/>
-            <a:ext cx="7040880" cy="4937760"/>
+          <p:cNvPr id="17" name="panel"/>
+          <p:cNvSpPr/>
+          <p:nvPr/>
+        </p:nvSpPr>
+        <p:spPr>
+          <a:xfrm>
+            <a:off x="457200" y="1325880"/>
+            <a:ext cx="6858000" cy="4892040"/>
           </a:xfrm>
           <a:prstGeom prst="rect">
             <a:avLst/>
@@ -1326,14 +1779,41 @@
       </p:sp>
       <p:sp>
         <p:nvSpPr>
-          <p:cNvPr id="17" name="body"/>
+          <p:cNvPr id="18" name="panelbar"/>
+          <p:cNvSpPr/>
+          <p:nvPr/>
+        </p:nvSpPr>
+        <p:spPr>
+          <a:xfrm>
+            <a:off x="457200" y="1325880"/>
+            <a:ext cx="73152" cy="4892040"/>
+          </a:xfrm>
+          <a:prstGeom prst="rect">
+            <a:avLst/>
+          </a:prstGeom>
+          <a:solidFill>
+            <a:srgbClr val="00C2D1"/>
+          </a:solidFill>
+          <a:ln>
+            <a:noFill/>
+          </a:ln>
+        </p:spPr>
+        <p:txBody>
+          <a:bodyPr/>
+          <a:lstStyle/>
+          <a:p/>
+        </p:txBody>
+      </p:sp>
+      <p:sp>
+        <p:nvSpPr>
+          <p:cNvPr id="19" name="body"/>
           <p:cNvSpPr txBox="1"/>
           <p:nvPr/>
         </p:nvSpPr>
         <p:spPr>
           <a:xfrm>
-            <a:off x="731520" y="1691640"/>
-            <a:ext cx="6492240" cy="4480560"/>
+            <a:off x="868680" y="1600200"/>
+            <a:ext cx="6126480" cy="4572000"/>
           </a:xfrm>
           <a:prstGeom prst="rect">
             <a:avLst/>
@@ -1347,24 +1827,51 @@
           <a:lstStyle/>
           <a:p>
             <a:pPr>
+              <a:spcBef>
+                <a:spcPts val="600"/>
+              </a:spcBef>
+              <a:spcAft>
+                <a:spcPts val="800"/>
+              </a:spcAft>
+            </a:pPr>
+            <a:r>
+              <a:rPr lang="uz-UZ" sz="1800" b="1" dirty="0">
+                <a:solidFill>
+                  <a:srgbClr val="00C2D1"/>
+                </a:solidFill>
+                <a:latin typeface="Times New Roman"/>
+                <a:cs typeface="Times New Roman"/>
+                <a:ea typeface="Times New Roman"/>
+              </a:rPr>
+              <a:t>Kichkina USB qurilmasiga minglab yuqori sifatli rasmlar qanday sig'adi?</a:t>
+            </a:r>
+          </a:p>
+          <a:p>
+            <a:pPr marL="256032" indent="0">
+              <a:spcBef>
+                <a:spcPts val="400"/>
+              </a:spcBef>
               <a:spcAft>
                 <a:spcPts val="1000"/>
               </a:spcAft>
             </a:pPr>
             <a:r>
-              <a:rPr lang="uz-UZ" sz="1800" b="1" dirty="0">
-                <a:solidFill>
-                  <a:srgbClr val="00C2D1"/>
-                </a:solidFill>
-                <a:latin typeface="Times New Roman"/>
-                <a:cs typeface="Times New Roman"/>
-                <a:ea typeface="Times New Roman"/>
-              </a:rPr>
-              <a:t>Kichkina USB qurilmasiga minglab yuqori sifatli rasmlar qanday sig'adi?</a:t>
-            </a:r>
-          </a:p>
-          <a:p>
-            <a:pPr>
+              <a:rPr lang="uz-UZ" sz="1600" dirty="0">
+                <a:solidFill>
+                  <a:srgbClr val="E2E8F0"/>
+                </a:solidFill>
+                <a:latin typeface="Times New Roman"/>
+                <a:cs typeface="Times New Roman"/>
+                <a:ea typeface="Times New Roman"/>
+              </a:rPr>
+              <a:t>- Buning siri tranzistorlarning o'lchamidadir. Zamonaviy fleshkalardagi bitta tranzistor (ma'lumot saqlovchi katakcha) inson sochidan minglab marta ingichka bo'ladi.</a:t>
+            </a:r>
+          </a:p>
+          <a:p>
+            <a:pPr marL="256032" indent="0">
+              <a:spcBef>
+                <a:spcPts val="400"/>
+              </a:spcBef>
               <a:spcAft>
                 <a:spcPts val="1000"/>
               </a:spcAft>
@@ -1378,17 +1885,62 @@
                 <a:cs typeface="Times New Roman"/>
                 <a:ea typeface="Times New Roman"/>
               </a:rPr>
-              <a:t>- Buning siri tranzistorlarning o'lchamidadir. Zamonaviy fleshkalardagi bitta tranzistor (ma'lumot saqlovchi katakcha) inson sochidan minglab marta ingichka bo'ladi.</a:t>
-            </a:r>
-          </a:p>
-          <a:p>
-            <a:pPr>
-              <a:spcAft>
-                <a:spcPts val="1000"/>
-              </a:spcAft>
-            </a:pPr>
-            <a:r>
-              <a:rPr lang="uz-UZ" sz="1600" dirty="0">
+              <a:t>- Ularning milliardlab donasi bitta kremniy (Silicon) kristaliga zichlashtiriladi. Kompyuterdan kelgan har bir rasm va hujjat aynan shu mitti katakchalarga elektr zaryadi tariqasida taqsimlanadi.</a:t>
+            </a:r>
+          </a:p>
+        </p:txBody>
+      </p:sp>
+      <p:sp>
+        <p:nvSpPr>
+          <p:cNvPr id="20" name="footline"/>
+          <p:cNvSpPr/>
+          <p:nvPr/>
+        </p:nvSpPr>
+        <p:spPr>
+          <a:xfrm>
+            <a:off x="548640" y="6419088"/>
+            <a:ext cx="11091672" cy="10972"/>
+          </a:xfrm>
+          <a:prstGeom prst="rect">
+            <a:avLst/>
+          </a:prstGeom>
+          <a:solidFill>
+            <a:srgbClr val="122A45"/>
+          </a:solidFill>
+          <a:ln>
+            <a:noFill/>
+          </a:ln>
+        </p:spPr>
+        <p:txBody>
+          <a:bodyPr/>
+          <a:lstStyle/>
+          <a:p/>
+        </p:txBody>
+      </p:sp>
+      <p:sp>
+        <p:nvSpPr>
+          <p:cNvPr id="21" name="foot_l"/>
+          <p:cNvSpPr txBox="1"/>
+          <p:nvPr/>
+        </p:nvSpPr>
+        <p:spPr>
+          <a:xfrm>
+            <a:off x="548640" y="6455664"/>
+            <a:ext cx="8229600" cy="365760"/>
+          </a:xfrm>
+          <a:prstGeom prst="rect">
+            <a:avLst/>
+          </a:prstGeom>
+          <a:noFill/>
+        </p:spPr>
+        <p:txBody>
+          <a:bodyPr wrap="square" anchor="ctr">
+            <a:normAutofit/>
+          </a:bodyPr>
+          <a:lstStyle/>
+          <a:p>
+            <a:r>
+              <a:rPr lang="uz-UZ" sz="1400" dirty="0">
                 <a:solidFill>
                   <a:srgbClr val="E2E8F0"/>
                 </a:solidFill>
@@ -1396,7 +1948,44 @@
                 <a:cs typeface="Times New Roman"/>
                 <a:ea typeface="Times New Roman"/>
               </a:rPr>
-              <a:t>- Ularning milliardlab donasi bitta kremniy (Silicon) kristaliga zichlashtiriladi. Kompyuterdan kelgan har bir rasm va hujjat aynan shu mitti katakchalarga elektr zaryadi tariqasida taqsimlanadi.</a:t>
+              <a:t>Fleshkalar (USB) qanday ishlaydi?</a:t>
+            </a:r>
+          </a:p>
+        </p:txBody>
+      </p:sp>
+      <p:sp>
+        <p:nvSpPr>
+          <p:cNvPr id="22" name="foot_r"/>
+          <p:cNvSpPr txBox="1"/>
+          <p:nvPr/>
+        </p:nvSpPr>
+        <p:spPr>
+          <a:xfrm>
+            <a:off x="8961120" y="6455664"/>
+            <a:ext cx="2679192" cy="365760"/>
+          </a:xfrm>
+          <a:prstGeom prst="rect">
+            <a:avLst/>
+          </a:prstGeom>
+          <a:noFill/>
+        </p:spPr>
+        <p:txBody>
+          <a:bodyPr wrap="square" anchor="ctr">
+            <a:normAutofit/>
+          </a:bodyPr>
+          <a:lstStyle/>
+          <a:p>
+            <a:pPr algn="r"/>
+            <a:r>
+              <a:rPr lang="uz-UZ" sz="1400" b="1" dirty="0">
+                <a:solidFill>
+                  <a:srgbClr val="00C2D1"/>
+                </a:solidFill>
+                <a:latin typeface="Times New Roman"/>
+                <a:cs typeface="Times New Roman"/>
+                <a:ea typeface="Times New Roman"/>
+              </a:rPr>
+              <a:t>4 / 10</a:t>
             </a:r>
           </a:p>
         </p:txBody>
@@ -1455,14 +2044,14 @@
       </p:sp>
       <p:sp>
         <p:nvSpPr>
-          <p:cNvPr id="12" name="topbar"/>
-          <p:cNvSpPr/>
-          <p:nvPr/>
-        </p:nvSpPr>
-        <p:spPr>
-          <a:xfrm>
-            <a:off x="0" y="1051560"/>
-            <a:ext cx="12191695" cy="45720"/>
+          <p:cNvPr id="12" name="tbar"/>
+          <p:cNvSpPr/>
+          <p:nvPr/>
+        </p:nvSpPr>
+        <p:spPr>
+          <a:xfrm>
+            <a:off x="548640" y="301752"/>
+            <a:ext cx="128016" cy="566928"/>
           </a:xfrm>
           <a:prstGeom prst="rect">
             <a:avLst/>
@@ -1482,41 +2071,14 @@
       </p:sp>
       <p:sp>
         <p:nvSpPr>
-          <p:cNvPr id="13" name="tbar"/>
-          <p:cNvSpPr/>
-          <p:nvPr/>
-        </p:nvSpPr>
-        <p:spPr>
-          <a:xfrm>
-            <a:off x="548640" y="320040"/>
-            <a:ext cx="109728" cy="548640"/>
-          </a:xfrm>
-          <a:prstGeom prst="rect">
-            <a:avLst/>
-          </a:prstGeom>
-          <a:solidFill>
-            <a:srgbClr val="00C2D1"/>
-          </a:solidFill>
-          <a:ln>
-            <a:noFill/>
-          </a:ln>
-        </p:spPr>
-        <p:txBody>
-          <a:bodyPr/>
-          <a:lstStyle/>
-          <a:p/>
-        </p:txBody>
-      </p:sp>
-      <p:sp>
-        <p:nvSpPr>
-          <p:cNvPr id="14" name="title"/>
+          <p:cNvPr id="13" name="title"/>
           <p:cNvSpPr txBox="1"/>
           <p:nvPr/>
         </p:nvSpPr>
         <p:spPr>
           <a:xfrm>
-            <a:off x="822960" y="274320"/>
-            <a:ext cx="10789920" cy="822960"/>
+            <a:off x="868680" y="256032"/>
+            <a:ext cx="10789920" cy="713232"/>
           </a:xfrm>
           <a:prstGeom prst="rect">
             <a:avLst/>
@@ -1543,11 +2105,67 @@
           </a:p>
         </p:txBody>
       </p:sp>
+      <p:sp>
+        <p:nvSpPr>
+          <p:cNvPr id="14" name="topbar"/>
+          <p:cNvSpPr/>
+          <p:nvPr/>
+        </p:nvSpPr>
+        <p:spPr>
+          <a:xfrm>
+            <a:off x="548640" y="1024128"/>
+            <a:ext cx="11091672" cy="36576"/>
+          </a:xfrm>
+          <a:prstGeom prst="rect">
+            <a:avLst/>
+          </a:prstGeom>
+          <a:solidFill>
+            <a:srgbClr val="00C2D1"/>
+          </a:solidFill>
+          <a:ln>
+            <a:noFill/>
+          </a:ln>
+        </p:spPr>
+        <p:txBody>
+          <a:bodyPr/>
+          <a:lstStyle/>
+          <a:p/>
+        </p:txBody>
+      </p:sp>
+      <p:sp>
+        <p:nvSpPr>
+          <p:cNvPr id="15" name="imgpanel"/>
+          <p:cNvSpPr/>
+          <p:nvPr/>
+        </p:nvSpPr>
+        <p:spPr>
+          <a:xfrm>
+            <a:off x="7635240" y="1325880"/>
+            <a:ext cx="4005072" cy="4892040"/>
+          </a:xfrm>
+          <a:prstGeom prst="rect">
+            <a:avLst/>
+          </a:prstGeom>
+          <a:solidFill>
+            <a:srgbClr val="122A45"/>
+          </a:solidFill>
+          <a:ln w="12700">
+            <a:solidFill>
+              <a:srgbClr val="3B82F6"/>
+            </a:solidFill>
+          </a:ln>
+        </p:spPr>
+        <p:txBody>
+          <a:bodyPr/>
+          <a:lstStyle/>
+          <a:p/>
+        </p:txBody>
+      </p:sp>
       <p:pic>
         <p:nvPicPr>
-          <p:cNvPr id="15" name="img"/>
+          <p:cNvPr id="16" name="img"/>
           <p:cNvPicPr>
-            <a:picLocks noChangeAspect="0"/>
+            <a:picLocks noChangeAspect="1"/>
           </p:cNvPicPr>
           <p:nvPr/>
         </p:nvPicPr>
@@ -1559,8 +2177,8 @@
         </p:blipFill>
         <p:spPr>
           <a:xfrm>
-            <a:off x="7772400" y="1463040"/>
-            <a:ext cx="3931920" cy="4937760"/>
+            <a:off x="7799832" y="1933956"/>
+            <a:ext cx="3675888" cy="3675888"/>
           </a:xfrm>
           <a:prstGeom prst="rect">
             <a:avLst/>
@@ -1569,14 +2187,14 @@
       </p:pic>
       <p:sp>
         <p:nvSpPr>
-          <p:cNvPr id="16" name="panel"/>
-          <p:cNvSpPr/>
-          <p:nvPr/>
-        </p:nvSpPr>
-        <p:spPr>
-          <a:xfrm>
-            <a:off x="457200" y="1463040"/>
-            <a:ext cx="7040880" cy="4937760"/>
+          <p:cNvPr id="17" name="panel"/>
+          <p:cNvSpPr/>
+          <p:nvPr/>
+        </p:nvSpPr>
+        <p:spPr>
+          <a:xfrm>
+            <a:off x="457200" y="1325880"/>
+            <a:ext cx="6858000" cy="4892040"/>
           </a:xfrm>
           <a:prstGeom prst="rect">
             <a:avLst/>
@@ -1596,14 +2214,41 @@
       </p:sp>
       <p:sp>
         <p:nvSpPr>
-          <p:cNvPr id="17" name="body"/>
+          <p:cNvPr id="18" name="panelbar"/>
+          <p:cNvSpPr/>
+          <p:nvPr/>
+        </p:nvSpPr>
+        <p:spPr>
+          <a:xfrm>
+            <a:off x="457200" y="1325880"/>
+            <a:ext cx="73152" cy="4892040"/>
+          </a:xfrm>
+          <a:prstGeom prst="rect">
+            <a:avLst/>
+          </a:prstGeom>
+          <a:solidFill>
+            <a:srgbClr val="00C2D1"/>
+          </a:solidFill>
+          <a:ln>
+            <a:noFill/>
+          </a:ln>
+        </p:spPr>
+        <p:txBody>
+          <a:bodyPr/>
+          <a:lstStyle/>
+          <a:p/>
+        </p:txBody>
+      </p:sp>
+      <p:sp>
+        <p:nvSpPr>
+          <p:cNvPr id="19" name="body"/>
           <p:cNvSpPr txBox="1"/>
           <p:nvPr/>
         </p:nvSpPr>
         <p:spPr>
           <a:xfrm>
-            <a:off x="731520" y="1691640"/>
-            <a:ext cx="6492240" cy="4480560"/>
+            <a:off x="868680" y="1600200"/>
+            <a:ext cx="6126480" cy="4572000"/>
           </a:xfrm>
           <a:prstGeom prst="rect">
             <a:avLst/>
@@ -1617,11 +2262,98 @@
           <a:lstStyle/>
           <a:p>
             <a:pPr>
+              <a:spcBef>
+                <a:spcPts val="600"/>
+              </a:spcBef>
+              <a:spcAft>
+                <a:spcPts val="800"/>
+              </a:spcAft>
+            </a:pPr>
+            <a:r>
+              <a:rPr lang="uz-UZ" sz="1800" b="1" dirty="0">
+                <a:solidFill>
+                  <a:srgbClr val="00C2D1"/>
+                </a:solidFill>
+                <a:latin typeface="Times New Roman"/>
+                <a:cs typeface="Times New Roman"/>
+                <a:ea typeface="Times New Roman"/>
+              </a:rPr>
+              <a:t>Fleshkadagi ma'lumot elektr toki uzilganda (kompyuterdan sug'urilganda) nega o'chib ketmaydi?</a:t>
+            </a:r>
+          </a:p>
+          <a:p>
+            <a:pPr>
+              <a:spcBef>
+                <a:spcPts val="600"/>
+              </a:spcBef>
+              <a:spcAft>
+                <a:spcPts val="800"/>
+              </a:spcAft>
+            </a:pPr>
+            <a:r>
+              <a:rPr lang="uz-UZ" sz="1800" b="1" dirty="0">
+                <a:solidFill>
+                  <a:srgbClr val="00C2D1"/>
+                </a:solidFill>
+                <a:latin typeface="Times New Roman"/>
+                <a:cs typeface="Times New Roman"/>
+                <a:ea typeface="Times New Roman"/>
+              </a:rPr>
+              <a:t>Sababi oddiy tranzistorlardan farqli o'laroq, fleshkalar "Suzuvchi zulfin" (Floating Gate) deb nomlanuvchi maxsus tranzistorlardan foydalanadi.</a:t>
+            </a:r>
+          </a:p>
+          <a:p>
+            <a:pPr>
+              <a:spcBef>
+                <a:spcPts val="600"/>
+              </a:spcBef>
+              <a:spcAft>
+                <a:spcPts val="800"/>
+              </a:spcAft>
+            </a:pPr>
+            <a:r>
+              <a:rPr lang="uz-UZ" sz="1800" b="1" dirty="0">
+                <a:solidFill>
+                  <a:srgbClr val="00C2D1"/>
+                </a:solidFill>
+                <a:latin typeface="Times New Roman"/>
+                <a:cs typeface="Times New Roman"/>
+                <a:ea typeface="Times New Roman"/>
+              </a:rPr>
+              <a:t>Izolyatsiya:</a:t>
+            </a:r>
+          </a:p>
+          <a:p>
+            <a:pPr marL="256032" indent="0">
+              <a:spcBef>
+                <a:spcPts val="400"/>
+              </a:spcBef>
               <a:spcAft>
                 <a:spcPts val="1000"/>
               </a:spcAft>
             </a:pPr>
             <a:r>
+              <a:rPr lang="uz-UZ" sz="1600" dirty="0">
+                <a:solidFill>
+                  <a:srgbClr val="E2E8F0"/>
+                </a:solidFill>
+                <a:latin typeface="Times New Roman"/>
+                <a:cs typeface="Times New Roman"/>
+                <a:ea typeface="Times New Roman"/>
+              </a:rPr>
+              <a:t>- Bu zulfin elektr tokini o'tkazmaydigan o'ta yupqa oksid qatlami bilan har tomondan to'liq o'rab olingan (qamalgan).</a:t>
+            </a:r>
+          </a:p>
+          <a:p>
+            <a:pPr>
+              <a:spcBef>
+                <a:spcPts val="600"/>
+              </a:spcBef>
+              <a:spcAft>
+                <a:spcPts val="800"/>
+              </a:spcAft>
+            </a:pPr>
+            <a:r>
               <a:rPr lang="uz-UZ" sz="1800" b="1" dirty="0">
                 <a:solidFill>
                   <a:srgbClr val="00C2D1"/>
@@ -1630,17 +2362,120 @@
                 <a:cs typeface="Times New Roman"/>
                 <a:ea typeface="Times New Roman"/>
               </a:rPr>
-              <a:t>Fleshkadagi ma'lumot elektr toki uzilganda (kompyuterdan sug'urilganda) nega o'chib ketmaydi?</a:t>
-            </a:r>
-          </a:p>
-          <a:p>
-            <a:pPr>
+              <a:t>Qopqonga tushgan elektronlar:</a:t>
+            </a:r>
+          </a:p>
+          <a:p>
+            <a:pPr marL="256032" indent="0">
+              <a:spcBef>
+                <a:spcPts val="400"/>
+              </a:spcBef>
               <a:spcAft>
                 <a:spcPts val="1000"/>
               </a:spcAft>
             </a:pPr>
             <a:r>
-              <a:rPr lang="uz-UZ" sz="1800" b="1" dirty="0">
+              <a:rPr lang="uz-UZ" sz="1600" dirty="0">
+                <a:solidFill>
+                  <a:srgbClr val="E2E8F0"/>
+                </a:solidFill>
+                <a:latin typeface="Times New Roman"/>
+                <a:cs typeface="Times New Roman"/>
+                <a:ea typeface="Times New Roman"/>
+              </a:rPr>
+              <a:t>- Agar elektronlar bu zulfin ichiga kiritilsa, ular u yerdan chiqa olmay, yillab qamalib qoladi.</a:t>
+            </a:r>
+          </a:p>
+        </p:txBody>
+      </p:sp>
+      <p:sp>
+        <p:nvSpPr>
+          <p:cNvPr id="20" name="footline"/>
+          <p:cNvSpPr/>
+          <p:nvPr/>
+        </p:nvSpPr>
+        <p:spPr>
+          <a:xfrm>
+            <a:off x="548640" y="6419088"/>
+            <a:ext cx="11091672" cy="10972"/>
+          </a:xfrm>
+          <a:prstGeom prst="rect">
+            <a:avLst/>
+          </a:prstGeom>
+          <a:solidFill>
+            <a:srgbClr val="122A45"/>
+          </a:solidFill>
+          <a:ln>
+            <a:noFill/>
+          </a:ln>
+        </p:spPr>
+        <p:txBody>
+          <a:bodyPr/>
+          <a:lstStyle/>
+          <a:p/>
+        </p:txBody>
+      </p:sp>
+      <p:sp>
+        <p:nvSpPr>
+          <p:cNvPr id="21" name="foot_l"/>
+          <p:cNvSpPr txBox="1"/>
+          <p:nvPr/>
+        </p:nvSpPr>
+        <p:spPr>
+          <a:xfrm>
+            <a:off x="548640" y="6455664"/>
+            <a:ext cx="8229600" cy="365760"/>
+          </a:xfrm>
+          <a:prstGeom prst="rect">
+            <a:avLst/>
+          </a:prstGeom>
+          <a:noFill/>
+        </p:spPr>
+        <p:txBody>
+          <a:bodyPr wrap="square" anchor="ctr">
+            <a:normAutofit/>
+          </a:bodyPr>
+          <a:lstStyle/>
+          <a:p>
+            <a:r>
+              <a:rPr lang="uz-UZ" sz="1400" dirty="0">
+                <a:solidFill>
+                  <a:srgbClr val="E2E8F0"/>
+                </a:solidFill>
+                <a:latin typeface="Times New Roman"/>
+                <a:cs typeface="Times New Roman"/>
+                <a:ea typeface="Times New Roman"/>
+              </a:rPr>
+              <a:t>Fleshkalar (USB) qanday ishlaydi?</a:t>
+            </a:r>
+          </a:p>
+        </p:txBody>
+      </p:sp>
+      <p:sp>
+        <p:nvSpPr>
+          <p:cNvPr id="22" name="foot_r"/>
+          <p:cNvSpPr txBox="1"/>
+          <p:nvPr/>
+        </p:nvSpPr>
+        <p:spPr>
+          <a:xfrm>
+            <a:off x="8961120" y="6455664"/>
+            <a:ext cx="2679192" cy="365760"/>
+          </a:xfrm>
+          <a:prstGeom prst="rect">
+            <a:avLst/>
+          </a:prstGeom>
+          <a:noFill/>
+        </p:spPr>
+        <p:txBody>
+          <a:bodyPr wrap="square" anchor="ctr">
+            <a:normAutofit/>
+          </a:bodyPr>
+          <a:lstStyle/>
+          <a:p>
+            <a:pPr algn="r"/>
+            <a:r>
+              <a:rPr lang="uz-UZ" sz="1400" b="1" dirty="0">
                 <a:solidFill>
                   <a:srgbClr val="00C2D1"/>
                 </a:solidFill>
@@ -1648,79 +2483,7 @@
                 <a:cs typeface="Times New Roman"/>
                 <a:ea typeface="Times New Roman"/>
               </a:rPr>
-              <a:t>Sababi oddiy tranzistorlardan farqli o'laroq, fleshkalar "Suzuvchi zulfin" (Floating Gate) deb nomlanuvchi maxsus tranzistorlardan foydalanadi.</a:t>
-            </a:r>
-          </a:p>
-          <a:p>
-            <a:pPr>
-              <a:spcAft>
-                <a:spcPts val="1000"/>
-              </a:spcAft>
-            </a:pPr>
-            <a:r>
-              <a:rPr lang="uz-UZ" sz="1800" b="1" dirty="0">
-                <a:solidFill>
-                  <a:srgbClr val="00C2D1"/>
-                </a:solidFill>
-                <a:latin typeface="Times New Roman"/>
-                <a:cs typeface="Times New Roman"/>
-                <a:ea typeface="Times New Roman"/>
-              </a:rPr>
-              <a:t>Izolyatsiya:</a:t>
-            </a:r>
-          </a:p>
-          <a:p>
-            <a:pPr>
-              <a:spcAft>
-                <a:spcPts val="1000"/>
-              </a:spcAft>
-            </a:pPr>
-            <a:r>
-              <a:rPr lang="uz-UZ" sz="1600" dirty="0">
-                <a:solidFill>
-                  <a:srgbClr val="E2E8F0"/>
-                </a:solidFill>
-                <a:latin typeface="Times New Roman"/>
-                <a:cs typeface="Times New Roman"/>
-                <a:ea typeface="Times New Roman"/>
-              </a:rPr>
-              <a:t>- Bu zulfin elektr tokini o'tkazmaydigan o'ta yupqa oksid qatlami bilan har tomondan to'liq o'rab olingan (qamalgan).</a:t>
-            </a:r>
-          </a:p>
-          <a:p>
-            <a:pPr>
-              <a:spcAft>
-                <a:spcPts val="1000"/>
-              </a:spcAft>
-            </a:pPr>
-            <a:r>
-              <a:rPr lang="uz-UZ" sz="1800" b="1" dirty="0">
-                <a:solidFill>
-                  <a:srgbClr val="00C2D1"/>
-                </a:solidFill>
-                <a:latin typeface="Times New Roman"/>
-                <a:cs typeface="Times New Roman"/>
-                <a:ea typeface="Times New Roman"/>
-              </a:rPr>
-              <a:t>Qopqonga tushgan elektronlar:</a:t>
-            </a:r>
-          </a:p>
-          <a:p>
-            <a:pPr>
-              <a:spcAft>
-                <a:spcPts val="1000"/>
-              </a:spcAft>
-            </a:pPr>
-            <a:r>
-              <a:rPr lang="uz-UZ" sz="1600" dirty="0">
-                <a:solidFill>
-                  <a:srgbClr val="E2E8F0"/>
-                </a:solidFill>
-                <a:latin typeface="Times New Roman"/>
-                <a:cs typeface="Times New Roman"/>
-                <a:ea typeface="Times New Roman"/>
-              </a:rPr>
-              <a:t>- Agar elektronlar bu zulfin ichiga kiritilsa, ular u yerdan chiqa olmay, yillab qamalib qoladi.</a:t>
+              <a:t>5 / 10</a:t>
             </a:r>
           </a:p>
         </p:txBody>
@@ -1779,14 +2542,14 @@
       </p:sp>
       <p:sp>
         <p:nvSpPr>
-          <p:cNvPr id="12" name="topbar"/>
-          <p:cNvSpPr/>
-          <p:nvPr/>
-        </p:nvSpPr>
-        <p:spPr>
-          <a:xfrm>
-            <a:off x="0" y="1051560"/>
-            <a:ext cx="12191695" cy="45720"/>
+          <p:cNvPr id="12" name="tbar"/>
+          <p:cNvSpPr/>
+          <p:nvPr/>
+        </p:nvSpPr>
+        <p:spPr>
+          <a:xfrm>
+            <a:off x="548640" y="301752"/>
+            <a:ext cx="128016" cy="566928"/>
           </a:xfrm>
           <a:prstGeom prst="rect">
             <a:avLst/>
@@ -1806,41 +2569,14 @@
       </p:sp>
       <p:sp>
         <p:nvSpPr>
-          <p:cNvPr id="13" name="tbar"/>
-          <p:cNvSpPr/>
-          <p:nvPr/>
-        </p:nvSpPr>
-        <p:spPr>
-          <a:xfrm>
-            <a:off x="548640" y="320040"/>
-            <a:ext cx="109728" cy="548640"/>
-          </a:xfrm>
-          <a:prstGeom prst="rect">
-            <a:avLst/>
-          </a:prstGeom>
-          <a:solidFill>
-            <a:srgbClr val="00C2D1"/>
-          </a:solidFill>
-          <a:ln>
-            <a:noFill/>
-          </a:ln>
-        </p:spPr>
-        <p:txBody>
-          <a:bodyPr/>
-          <a:lstStyle/>
-          <a:p/>
-        </p:txBody>
-      </p:sp>
-      <p:sp>
-        <p:nvSpPr>
-          <p:cNvPr id="14" name="title"/>
+          <p:cNvPr id="13" name="title"/>
           <p:cNvSpPr txBox="1"/>
           <p:nvPr/>
         </p:nvSpPr>
         <p:spPr>
           <a:xfrm>
-            <a:off x="822960" y="274320"/>
-            <a:ext cx="10789920" cy="822960"/>
+            <a:off x="868680" y="256032"/>
+            <a:ext cx="10789920" cy="713232"/>
           </a:xfrm>
           <a:prstGeom prst="rect">
             <a:avLst/>
@@ -1867,11 +2603,67 @@
           </a:p>
         </p:txBody>
       </p:sp>
+      <p:sp>
+        <p:nvSpPr>
+          <p:cNvPr id="14" name="topbar"/>
+          <p:cNvSpPr/>
+          <p:nvPr/>
+        </p:nvSpPr>
+        <p:spPr>
+          <a:xfrm>
+            <a:off x="548640" y="1024128"/>
+            <a:ext cx="11091672" cy="36576"/>
+          </a:xfrm>
+          <a:prstGeom prst="rect">
+            <a:avLst/>
+          </a:prstGeom>
+          <a:solidFill>
+            <a:srgbClr val="00C2D1"/>
+          </a:solidFill>
+          <a:ln>
+            <a:noFill/>
+          </a:ln>
+        </p:spPr>
+        <p:txBody>
+          <a:bodyPr/>
+          <a:lstStyle/>
+          <a:p/>
+        </p:txBody>
+      </p:sp>
+      <p:sp>
+        <p:nvSpPr>
+          <p:cNvPr id="15" name="imgpanel"/>
+          <p:cNvSpPr/>
+          <p:nvPr/>
+        </p:nvSpPr>
+        <p:spPr>
+          <a:xfrm>
+            <a:off x="7635240" y="1325880"/>
+            <a:ext cx="4005072" cy="4892040"/>
+          </a:xfrm>
+          <a:prstGeom prst="rect">
+            <a:avLst/>
+          </a:prstGeom>
+          <a:solidFill>
+            <a:srgbClr val="122A45"/>
+          </a:solidFill>
+          <a:ln w="12700">
+            <a:solidFill>
+              <a:srgbClr val="3B82F6"/>
+            </a:solidFill>
+          </a:ln>
+        </p:spPr>
+        <p:txBody>
+          <a:bodyPr/>
+          <a:lstStyle/>
+          <a:p/>
+        </p:txBody>
+      </p:sp>
       <p:pic>
         <p:nvPicPr>
-          <p:cNvPr id="15" name="img"/>
+          <p:cNvPr id="16" name="img"/>
           <p:cNvPicPr>
-            <a:picLocks noChangeAspect="0"/>
+            <a:picLocks noChangeAspect="1"/>
           </p:cNvPicPr>
           <p:nvPr/>
         </p:nvPicPr>
@@ -1883,8 +2675,8 @@
         </p:blipFill>
         <p:spPr>
           <a:xfrm>
-            <a:off x="7772400" y="1463040"/>
-            <a:ext cx="3931920" cy="4937760"/>
+            <a:off x="7799832" y="1933956"/>
+            <a:ext cx="3675888" cy="3675888"/>
           </a:xfrm>
           <a:prstGeom prst="rect">
             <a:avLst/>
@@ -1893,14 +2685,14 @@
       </p:pic>
       <p:sp>
         <p:nvSpPr>
-          <p:cNvPr id="16" name="panel"/>
-          <p:cNvSpPr/>
-          <p:nvPr/>
-        </p:nvSpPr>
-        <p:spPr>
-          <a:xfrm>
-            <a:off x="457200" y="1463040"/>
-            <a:ext cx="7040880" cy="4937760"/>
+          <p:cNvPr id="17" name="panel"/>
+          <p:cNvSpPr/>
+          <p:nvPr/>
+        </p:nvSpPr>
+        <p:spPr>
+          <a:xfrm>
+            <a:off x="457200" y="1325880"/>
+            <a:ext cx="6858000" cy="4892040"/>
           </a:xfrm>
           <a:prstGeom prst="rect">
             <a:avLst/>
@@ -1920,14 +2712,41 @@
       </p:sp>
       <p:sp>
         <p:nvSpPr>
-          <p:cNvPr id="17" name="body"/>
+          <p:cNvPr id="18" name="panelbar"/>
+          <p:cNvSpPr/>
+          <p:nvPr/>
+        </p:nvSpPr>
+        <p:spPr>
+          <a:xfrm>
+            <a:off x="457200" y="1325880"/>
+            <a:ext cx="73152" cy="4892040"/>
+          </a:xfrm>
+          <a:prstGeom prst="rect">
+            <a:avLst/>
+          </a:prstGeom>
+          <a:solidFill>
+            <a:srgbClr val="00C2D1"/>
+          </a:solidFill>
+          <a:ln>
+            <a:noFill/>
+          </a:ln>
+        </p:spPr>
+        <p:txBody>
+          <a:bodyPr/>
+          <a:lstStyle/>
+          <a:p/>
+        </p:txBody>
+      </p:sp>
+      <p:sp>
+        <p:nvSpPr>
+          <p:cNvPr id="19" name="body"/>
           <p:cNvSpPr txBox="1"/>
           <p:nvPr/>
         </p:nvSpPr>
         <p:spPr>
           <a:xfrm>
-            <a:off x="731520" y="1691640"/>
-            <a:ext cx="6492240" cy="4480560"/>
+            <a:off x="868680" y="1600200"/>
+            <a:ext cx="6126480" cy="4572000"/>
           </a:xfrm>
           <a:prstGeom prst="rect">
             <a:avLst/>
@@ -1941,11 +2760,77 @@
           <a:lstStyle/>
           <a:p>
             <a:pPr>
+              <a:spcBef>
+                <a:spcPts val="600"/>
+              </a:spcBef>
+              <a:spcAft>
+                <a:spcPts val="800"/>
+              </a:spcAft>
+            </a:pPr>
+            <a:r>
+              <a:rPr lang="uz-UZ" sz="1800" b="1" dirty="0">
+                <a:solidFill>
+                  <a:srgbClr val="00C2D1"/>
+                </a:solidFill>
+                <a:latin typeface="Times New Roman"/>
+                <a:cs typeface="Times New Roman"/>
+                <a:ea typeface="Times New Roman"/>
+              </a:rPr>
+              <a:t>Zulfin ichiga elektronlar kiritilgani yoki kiritilmagani axborotni o'qish imkonini beradi.</a:t>
+            </a:r>
+          </a:p>
+          <a:p>
+            <a:pPr>
+              <a:spcBef>
+                <a:spcPts val="600"/>
+              </a:spcBef>
+              <a:spcAft>
+                <a:spcPts val="800"/>
+              </a:spcAft>
+            </a:pPr>
+            <a:r>
+              <a:rPr lang="uz-UZ" sz="1800" b="1" dirty="0">
+                <a:solidFill>
+                  <a:srgbClr val="00C2D1"/>
+                </a:solidFill>
+                <a:latin typeface="Times New Roman"/>
+                <a:cs typeface="Times New Roman"/>
+                <a:ea typeface="Times New Roman"/>
+              </a:rPr>
+              <a:t>Mantiqiy "0":</a:t>
+            </a:r>
+          </a:p>
+          <a:p>
+            <a:pPr marL="256032" indent="0">
+              <a:spcBef>
+                <a:spcPts val="400"/>
+              </a:spcBef>
               <a:spcAft>
                 <a:spcPts val="1000"/>
               </a:spcAft>
             </a:pPr>
             <a:r>
+              <a:rPr lang="uz-UZ" sz="1600" dirty="0">
+                <a:solidFill>
+                  <a:srgbClr val="E2E8F0"/>
+                </a:solidFill>
+                <a:latin typeface="Times New Roman"/>
+                <a:cs typeface="Times New Roman"/>
+                <a:ea typeface="Times New Roman"/>
+              </a:rPr>
+              <a:t>- Suzuvchi zulfinda elektronlar qamalgan bo'lsa, ular tranzistor orqali asosiy elektr tokining o'tishiga to'sqinlik qiladi. Kompyuter buni "0" deb o'qiydi.</a:t>
+            </a:r>
+          </a:p>
+          <a:p>
+            <a:pPr>
+              <a:spcBef>
+                <a:spcPts val="600"/>
+              </a:spcBef>
+              <a:spcAft>
+                <a:spcPts val="800"/>
+              </a:spcAft>
+            </a:pPr>
+            <a:r>
               <a:rPr lang="uz-UZ" sz="1800" b="1" dirty="0">
                 <a:solidFill>
                   <a:srgbClr val="00C2D1"/>
@@ -1954,17 +2839,120 @@
                 <a:cs typeface="Times New Roman"/>
                 <a:ea typeface="Times New Roman"/>
               </a:rPr>
-              <a:t>Zulfin ichiga elektronlar kiritilgani yoki kiritilmagani axborotni o'qish imkonini beradi.</a:t>
-            </a:r>
-          </a:p>
-          <a:p>
-            <a:pPr>
+              <a:t>Mantiqiy "1":</a:t>
+            </a:r>
+          </a:p>
+          <a:p>
+            <a:pPr marL="256032" indent="0">
+              <a:spcBef>
+                <a:spcPts val="400"/>
+              </a:spcBef>
               <a:spcAft>
                 <a:spcPts val="1000"/>
               </a:spcAft>
             </a:pPr>
             <a:r>
-              <a:rPr lang="uz-UZ" sz="1800" b="1" dirty="0">
+              <a:rPr lang="uz-UZ" sz="1600" dirty="0">
+                <a:solidFill>
+                  <a:srgbClr val="E2E8F0"/>
+                </a:solidFill>
+                <a:latin typeface="Times New Roman"/>
+                <a:cs typeface="Times New Roman"/>
+                <a:ea typeface="Times New Roman"/>
+              </a:rPr>
+              <a:t>- Zulfinda elektronlar yo'q bo'lsa, elektr toki bemalol o'tadi va kompyuter buni "1" deb qabul qiladi. Shu tariqa fayllar fizik holatga ko'chadi.</a:t>
+            </a:r>
+          </a:p>
+        </p:txBody>
+      </p:sp>
+      <p:sp>
+        <p:nvSpPr>
+          <p:cNvPr id="20" name="footline"/>
+          <p:cNvSpPr/>
+          <p:nvPr/>
+        </p:nvSpPr>
+        <p:spPr>
+          <a:xfrm>
+            <a:off x="548640" y="6419088"/>
+            <a:ext cx="11091672" cy="10972"/>
+          </a:xfrm>
+          <a:prstGeom prst="rect">
+            <a:avLst/>
+          </a:prstGeom>
+          <a:solidFill>
+            <a:srgbClr val="122A45"/>
+          </a:solidFill>
+          <a:ln>
+            <a:noFill/>
+          </a:ln>
+        </p:spPr>
+        <p:txBody>
+          <a:bodyPr/>
+          <a:lstStyle/>
+          <a:p/>
+        </p:txBody>
+      </p:sp>
+      <p:sp>
+        <p:nvSpPr>
+          <p:cNvPr id="21" name="foot_l"/>
+          <p:cNvSpPr txBox="1"/>
+          <p:nvPr/>
+        </p:nvSpPr>
+        <p:spPr>
+          <a:xfrm>
+            <a:off x="548640" y="6455664"/>
+            <a:ext cx="8229600" cy="365760"/>
+          </a:xfrm>
+          <a:prstGeom prst="rect">
+            <a:avLst/>
+          </a:prstGeom>
+          <a:noFill/>
+        </p:spPr>
+        <p:txBody>
+          <a:bodyPr wrap="square" anchor="ctr">
+            <a:normAutofit/>
+          </a:bodyPr>
+          <a:lstStyle/>
+          <a:p>
+            <a:r>
+              <a:rPr lang="uz-UZ" sz="1400" dirty="0">
+                <a:solidFill>
+                  <a:srgbClr val="E2E8F0"/>
+                </a:solidFill>
+                <a:latin typeface="Times New Roman"/>
+                <a:cs typeface="Times New Roman"/>
+                <a:ea typeface="Times New Roman"/>
+              </a:rPr>
+              <a:t>Fleshkalar (USB) qanday ishlaydi?</a:t>
+            </a:r>
+          </a:p>
+        </p:txBody>
+      </p:sp>
+      <p:sp>
+        <p:nvSpPr>
+          <p:cNvPr id="22" name="foot_r"/>
+          <p:cNvSpPr txBox="1"/>
+          <p:nvPr/>
+        </p:nvSpPr>
+        <p:spPr>
+          <a:xfrm>
+            <a:off x="8961120" y="6455664"/>
+            <a:ext cx="2679192" cy="365760"/>
+          </a:xfrm>
+          <a:prstGeom prst="rect">
+            <a:avLst/>
+          </a:prstGeom>
+          <a:noFill/>
+        </p:spPr>
+        <p:txBody>
+          <a:bodyPr wrap="square" anchor="ctr">
+            <a:normAutofit/>
+          </a:bodyPr>
+          <a:lstStyle/>
+          <a:p>
+            <a:pPr algn="r"/>
+            <a:r>
+              <a:rPr lang="uz-UZ" sz="1400" b="1" dirty="0">
                 <a:solidFill>
                   <a:srgbClr val="00C2D1"/>
                 </a:solidFill>
@@ -1972,61 +2960,7 @@
                 <a:cs typeface="Times New Roman"/>
                 <a:ea typeface="Times New Roman"/>
               </a:rPr>
-              <a:t>Mantiqiy "0":</a:t>
-            </a:r>
-          </a:p>
-          <a:p>
-            <a:pPr>
-              <a:spcAft>
-                <a:spcPts val="1000"/>
-              </a:spcAft>
-            </a:pPr>
-            <a:r>
-              <a:rPr lang="uz-UZ" sz="1600" dirty="0">
-                <a:solidFill>
-                  <a:srgbClr val="E2E8F0"/>
-                </a:solidFill>
-                <a:latin typeface="Times New Roman"/>
-                <a:cs typeface="Times New Roman"/>
-                <a:ea typeface="Times New Roman"/>
-              </a:rPr>
-              <a:t>- Suzuvchi zulfinda elektronlar qamalgan bo'lsa, ular tranzistor orqali asosiy elektr tokining o'tishiga to'sqinlik qiladi. Kompyuter buni "0" deb o'qiydi.</a:t>
-            </a:r>
-          </a:p>
-          <a:p>
-            <a:pPr>
-              <a:spcAft>
-                <a:spcPts val="1000"/>
-              </a:spcAft>
-            </a:pPr>
-            <a:r>
-              <a:rPr lang="uz-UZ" sz="1800" b="1" dirty="0">
-                <a:solidFill>
-                  <a:srgbClr val="00C2D1"/>
-                </a:solidFill>
-                <a:latin typeface="Times New Roman"/>
-                <a:cs typeface="Times New Roman"/>
-                <a:ea typeface="Times New Roman"/>
-              </a:rPr>
-              <a:t>Mantiqiy "1":</a:t>
-            </a:r>
-          </a:p>
-          <a:p>
-            <a:pPr>
-              <a:spcAft>
-                <a:spcPts val="1000"/>
-              </a:spcAft>
-            </a:pPr>
-            <a:r>
-              <a:rPr lang="uz-UZ" sz="1600" dirty="0">
-                <a:solidFill>
-                  <a:srgbClr val="E2E8F0"/>
-                </a:solidFill>
-                <a:latin typeface="Times New Roman"/>
-                <a:cs typeface="Times New Roman"/>
-                <a:ea typeface="Times New Roman"/>
-              </a:rPr>
-              <a:t>- Zulfinda elektronlar yo'q bo'lsa, elektr toki bemalol o'tadi va kompyuter buni "1" deb qabul qiladi. Shu tariqa fayllar fizik holatga ko'chadi.</a:t>
+              <a:t>6 / 10</a:t>
             </a:r>
           </a:p>
         </p:txBody>
@@ -2085,14 +3019,14 @@
       </p:sp>
       <p:sp>
         <p:nvSpPr>
-          <p:cNvPr id="12" name="topbar"/>
-          <p:cNvSpPr/>
-          <p:nvPr/>
-        </p:nvSpPr>
-        <p:spPr>
-          <a:xfrm>
-            <a:off x="0" y="1051560"/>
-            <a:ext cx="12191695" cy="45720"/>
+          <p:cNvPr id="12" name="tbar"/>
+          <p:cNvSpPr/>
+          <p:nvPr/>
+        </p:nvSpPr>
+        <p:spPr>
+          <a:xfrm>
+            <a:off x="548640" y="301752"/>
+            <a:ext cx="128016" cy="566928"/>
           </a:xfrm>
           <a:prstGeom prst="rect">
             <a:avLst/>
@@ -2112,41 +3046,14 @@
       </p:sp>
       <p:sp>
         <p:nvSpPr>
-          <p:cNvPr id="13" name="tbar"/>
-          <p:cNvSpPr/>
-          <p:nvPr/>
-        </p:nvSpPr>
-        <p:spPr>
-          <a:xfrm>
-            <a:off x="548640" y="320040"/>
-            <a:ext cx="109728" cy="548640"/>
-          </a:xfrm>
-          <a:prstGeom prst="rect">
-            <a:avLst/>
-          </a:prstGeom>
-          <a:solidFill>
-            <a:srgbClr val="00C2D1"/>
-          </a:solidFill>
-          <a:ln>
-            <a:noFill/>
-          </a:ln>
-        </p:spPr>
-        <p:txBody>
-          <a:bodyPr/>
-          <a:lstStyle/>
-          <a:p/>
-        </p:txBody>
-      </p:sp>
-      <p:sp>
-        <p:nvSpPr>
-          <p:cNvPr id="14" name="title"/>
+          <p:cNvPr id="13" name="title"/>
           <p:cNvSpPr txBox="1"/>
           <p:nvPr/>
         </p:nvSpPr>
         <p:spPr>
           <a:xfrm>
-            <a:off x="822960" y="274320"/>
-            <a:ext cx="10789920" cy="822960"/>
+            <a:off x="868680" y="256032"/>
+            <a:ext cx="10789920" cy="713232"/>
           </a:xfrm>
           <a:prstGeom prst="rect">
             <a:avLst/>
@@ -2173,11 +3080,67 @@
           </a:p>
         </p:txBody>
       </p:sp>
+      <p:sp>
+        <p:nvSpPr>
+          <p:cNvPr id="14" name="topbar"/>
+          <p:cNvSpPr/>
+          <p:nvPr/>
+        </p:nvSpPr>
+        <p:spPr>
+          <a:xfrm>
+            <a:off x="548640" y="1024128"/>
+            <a:ext cx="11091672" cy="36576"/>
+          </a:xfrm>
+          <a:prstGeom prst="rect">
+            <a:avLst/>
+          </a:prstGeom>
+          <a:solidFill>
+            <a:srgbClr val="00C2D1"/>
+          </a:solidFill>
+          <a:ln>
+            <a:noFill/>
+          </a:ln>
+        </p:spPr>
+        <p:txBody>
+          <a:bodyPr/>
+          <a:lstStyle/>
+          <a:p/>
+        </p:txBody>
+      </p:sp>
+      <p:sp>
+        <p:nvSpPr>
+          <p:cNvPr id="15" name="imgpanel"/>
+          <p:cNvSpPr/>
+          <p:nvPr/>
+        </p:nvSpPr>
+        <p:spPr>
+          <a:xfrm>
+            <a:off x="7635240" y="1325880"/>
+            <a:ext cx="4005072" cy="4892040"/>
+          </a:xfrm>
+          <a:prstGeom prst="rect">
+            <a:avLst/>
+          </a:prstGeom>
+          <a:solidFill>
+            <a:srgbClr val="122A45"/>
+          </a:solidFill>
+          <a:ln w="12700">
+            <a:solidFill>
+              <a:srgbClr val="3B82F6"/>
+            </a:solidFill>
+          </a:ln>
+        </p:spPr>
+        <p:txBody>
+          <a:bodyPr/>
+          <a:lstStyle/>
+          <a:p/>
+        </p:txBody>
+      </p:sp>
       <p:pic>
         <p:nvPicPr>
-          <p:cNvPr id="15" name="img"/>
+          <p:cNvPr id="16" name="img"/>
           <p:cNvPicPr>
-            <a:picLocks noChangeAspect="0"/>
+            <a:picLocks noChangeAspect="1"/>
           </p:cNvPicPr>
           <p:nvPr/>
         </p:nvPicPr>
@@ -2189,8 +3152,8 @@
         </p:blipFill>
         <p:spPr>
           <a:xfrm>
-            <a:off x="7772400" y="1463040"/>
-            <a:ext cx="3931920" cy="4937760"/>
+            <a:off x="7799832" y="1933956"/>
+            <a:ext cx="3675888" cy="3675888"/>
           </a:xfrm>
           <a:prstGeom prst="rect">
             <a:avLst/>
@@ -2199,14 +3162,14 @@
       </p:pic>
       <p:sp>
         <p:nvSpPr>
-          <p:cNvPr id="16" name="panel"/>
-          <p:cNvSpPr/>
-          <p:nvPr/>
-        </p:nvSpPr>
-        <p:spPr>
-          <a:xfrm>
-            <a:off x="457200" y="1463040"/>
-            <a:ext cx="7040880" cy="4937760"/>
+          <p:cNvPr id="17" name="panel"/>
+          <p:cNvSpPr/>
+          <p:nvPr/>
+        </p:nvSpPr>
+        <p:spPr>
+          <a:xfrm>
+            <a:off x="457200" y="1325880"/>
+            <a:ext cx="6858000" cy="4892040"/>
           </a:xfrm>
           <a:prstGeom prst="rect">
             <a:avLst/>
@@ -2226,14 +3189,41 @@
       </p:sp>
       <p:sp>
         <p:nvSpPr>
-          <p:cNvPr id="17" name="body"/>
+          <p:cNvPr id="18" name="panelbar"/>
+          <p:cNvSpPr/>
+          <p:nvPr/>
+        </p:nvSpPr>
+        <p:spPr>
+          <a:xfrm>
+            <a:off x="457200" y="1325880"/>
+            <a:ext cx="73152" cy="4892040"/>
+          </a:xfrm>
+          <a:prstGeom prst="rect">
+            <a:avLst/>
+          </a:prstGeom>
+          <a:solidFill>
+            <a:srgbClr val="00C2D1"/>
+          </a:solidFill>
+          <a:ln>
+            <a:noFill/>
+          </a:ln>
+        </p:spPr>
+        <p:txBody>
+          <a:bodyPr/>
+          <a:lstStyle/>
+          <a:p/>
+        </p:txBody>
+      </p:sp>
+      <p:sp>
+        <p:nvSpPr>
+          <p:cNvPr id="19" name="body"/>
           <p:cNvSpPr txBox="1"/>
           <p:nvPr/>
         </p:nvSpPr>
         <p:spPr>
           <a:xfrm>
-            <a:off x="731520" y="1691640"/>
-            <a:ext cx="6492240" cy="4480560"/>
+            <a:off x="868680" y="1600200"/>
+            <a:ext cx="6126480" cy="4572000"/>
           </a:xfrm>
           <a:prstGeom prst="rect">
             <a:avLst/>
@@ -2247,12 +3237,178 @@
           <a:lstStyle/>
           <a:p>
             <a:pPr>
+              <a:spcBef>
+                <a:spcPts val="600"/>
+              </a:spcBef>
+              <a:spcAft>
+                <a:spcPts val="800"/>
+              </a:spcAft>
+            </a:pPr>
+            <a:r>
+              <a:rPr lang="uz-UZ" sz="1800" b="1" dirty="0">
+                <a:solidFill>
+                  <a:srgbClr val="00C2D1"/>
+                </a:solidFill>
+                <a:latin typeface="Times New Roman"/>
+                <a:cs typeface="Times New Roman"/>
+                <a:ea typeface="Times New Roman"/>
+              </a:rPr>
+              <a:t>Agar zulfin izolyator bilan to'liq o'ralgan bo'lsa, elektronlar uning ichiga qanday kiradi?</a:t>
+            </a:r>
+          </a:p>
+          <a:p>
+            <a:pPr>
+              <a:spcBef>
+                <a:spcPts val="600"/>
+              </a:spcBef>
+              <a:spcAft>
+                <a:spcPts val="800"/>
+              </a:spcAft>
+            </a:pPr>
+            <a:r>
+              <a:rPr lang="uz-UZ" sz="1800" b="1" dirty="0">
+                <a:solidFill>
+                  <a:srgbClr val="00C2D1"/>
+                </a:solidFill>
+                <a:latin typeface="Times New Roman"/>
+                <a:cs typeface="Times New Roman"/>
+                <a:ea typeface="Times New Roman"/>
+              </a:rPr>
+              <a:t>Aynan shu yerda Kvant mexanikasi ishga tushadi! Kompyuter fleshkaga fayl yozayotganda tranzistorga kuchli kuchlanish (Volt) beradi.</a:t>
+            </a:r>
+          </a:p>
+          <a:p>
+            <a:pPr>
+              <a:spcBef>
+                <a:spcPts val="600"/>
+              </a:spcBef>
+              <a:spcAft>
+                <a:spcPts val="800"/>
+              </a:spcAft>
+            </a:pPr>
+            <a:r>
+              <a:rPr lang="uz-UZ" sz="1800" b="1" dirty="0">
+                <a:solidFill>
+                  <a:srgbClr val="00C2D1"/>
+                </a:solidFill>
+                <a:latin typeface="Times New Roman"/>
+                <a:cs typeface="Times New Roman"/>
+                <a:ea typeface="Times New Roman"/>
+              </a:rPr>
+              <a:t>Fauler-Nordxeym (Fowler-Nordheim) tunnellanishi:</a:t>
+            </a:r>
+          </a:p>
+          <a:p>
+            <a:pPr marL="256032" indent="0">
+              <a:spcBef>
+                <a:spcPts val="400"/>
+              </a:spcBef>
               <a:spcAft>
                 <a:spcPts val="1000"/>
               </a:spcAft>
             </a:pPr>
             <a:r>
-              <a:rPr lang="uz-UZ" sz="1800" b="1" dirty="0">
+              <a:rPr lang="uz-UZ" sz="1600" dirty="0">
+                <a:solidFill>
+                  <a:srgbClr val="E2E8F0"/>
+                </a:solidFill>
+                <a:latin typeface="Times New Roman"/>
+                <a:cs typeface="Times New Roman"/>
+                <a:ea typeface="Times New Roman"/>
+              </a:rPr>
+              <a:t>- Kuchli elektr maydoni ta'sirida elektronlar "kutilmaganda" o'tib bo'lmas oksid to'sig'idan teshib o'tib, zulfin ichiga tushib qoladi. Bu mo'jizaviy kvant hodisasi axborotni fleshkaga yozish imkonini beradi.</a:t>
+            </a:r>
+          </a:p>
+        </p:txBody>
+      </p:sp>
+      <p:sp>
+        <p:nvSpPr>
+          <p:cNvPr id="20" name="footline"/>
+          <p:cNvSpPr/>
+          <p:nvPr/>
+        </p:nvSpPr>
+        <p:spPr>
+          <a:xfrm>
+            <a:off x="548640" y="6419088"/>
+            <a:ext cx="11091672" cy="10972"/>
+          </a:xfrm>
+          <a:prstGeom prst="rect">
+            <a:avLst/>
+          </a:prstGeom>
+          <a:solidFill>
+            <a:srgbClr val="122A45"/>
+          </a:solidFill>
+          <a:ln>
+            <a:noFill/>
+          </a:ln>
+        </p:spPr>
+        <p:txBody>
+          <a:bodyPr/>
+          <a:lstStyle/>
+          <a:p/>
+        </p:txBody>
+      </p:sp>
+      <p:sp>
+        <p:nvSpPr>
+          <p:cNvPr id="21" name="foot_l"/>
+          <p:cNvSpPr txBox="1"/>
+          <p:nvPr/>
+        </p:nvSpPr>
+        <p:spPr>
+          <a:xfrm>
+            <a:off x="548640" y="6455664"/>
+            <a:ext cx="8229600" cy="365760"/>
+          </a:xfrm>
+          <a:prstGeom prst="rect">
+            <a:avLst/>
+          </a:prstGeom>
+          <a:noFill/>
+        </p:spPr>
+        <p:txBody>
+          <a:bodyPr wrap="square" anchor="ctr">
+            <a:normAutofit/>
+          </a:bodyPr>
+          <a:lstStyle/>
+          <a:p>
+            <a:r>
+              <a:rPr lang="uz-UZ" sz="1400" dirty="0">
+                <a:solidFill>
+                  <a:srgbClr val="E2E8F0"/>
+                </a:solidFill>
+                <a:latin typeface="Times New Roman"/>
+                <a:cs typeface="Times New Roman"/>
+                <a:ea typeface="Times New Roman"/>
+              </a:rPr>
+              <a:t>Fleshkalar (USB) qanday ishlaydi?</a:t>
+            </a:r>
+          </a:p>
+        </p:txBody>
+      </p:sp>
+      <p:sp>
+        <p:nvSpPr>
+          <p:cNvPr id="22" name="foot_r"/>
+          <p:cNvSpPr txBox="1"/>
+          <p:nvPr/>
+        </p:nvSpPr>
+        <p:spPr>
+          <a:xfrm>
+            <a:off x="8961120" y="6455664"/>
+            <a:ext cx="2679192" cy="365760"/>
+          </a:xfrm>
+          <a:prstGeom prst="rect">
+            <a:avLst/>
+          </a:prstGeom>
+          <a:noFill/>
+        </p:spPr>
+        <p:txBody>
+          <a:bodyPr wrap="square" anchor="ctr">
+            <a:normAutofit/>
+          </a:bodyPr>
+          <a:lstStyle/>
+          <a:p>
+            <a:pPr algn="r"/>
+            <a:r>
+              <a:rPr lang="uz-UZ" sz="1400" b="1" dirty="0">
                 <a:solidFill>
                   <a:srgbClr val="00C2D1"/>
                 </a:solidFill>
@@ -2260,61 +3416,7 @@
                 <a:cs typeface="Times New Roman"/>
                 <a:ea typeface="Times New Roman"/>
               </a:rPr>
-              <a:t>Agar zulfin izolyator bilan to'liq o'ralgan bo'lsa, elektronlar uning ichiga qanday kiradi?</a:t>
-            </a:r>
-          </a:p>
-          <a:p>
-            <a:pPr>
-              <a:spcAft>
-                <a:spcPts val="1000"/>
-              </a:spcAft>
-            </a:pPr>
-            <a:r>
-              <a:rPr lang="uz-UZ" sz="1800" b="1" dirty="0">
-                <a:solidFill>
-                  <a:srgbClr val="00C2D1"/>
-                </a:solidFill>
-                <a:latin typeface="Times New Roman"/>
-                <a:cs typeface="Times New Roman"/>
-                <a:ea typeface="Times New Roman"/>
-              </a:rPr>
-              <a:t>Aynan shu yerda Kvant mexanikasi ishga tushadi! Kompyuter fleshkaga fayl yozayotganda tranzistorga kuchli kuchlanish (Volt) beradi.</a:t>
-            </a:r>
-          </a:p>
-          <a:p>
-            <a:pPr>
-              <a:spcAft>
-                <a:spcPts val="1000"/>
-              </a:spcAft>
-            </a:pPr>
-            <a:r>
-              <a:rPr lang="uz-UZ" sz="1800" b="1" dirty="0">
-                <a:solidFill>
-                  <a:srgbClr val="00C2D1"/>
-                </a:solidFill>
-                <a:latin typeface="Times New Roman"/>
-                <a:cs typeface="Times New Roman"/>
-                <a:ea typeface="Times New Roman"/>
-              </a:rPr>
-              <a:t>Fauler-Nordxeym (Fowler-Nordheim) tunnellanishi:</a:t>
-            </a:r>
-          </a:p>
-          <a:p>
-            <a:pPr>
-              <a:spcAft>
-                <a:spcPts val="1000"/>
-              </a:spcAft>
-            </a:pPr>
-            <a:r>
-              <a:rPr lang="uz-UZ" sz="1600" dirty="0">
-                <a:solidFill>
-                  <a:srgbClr val="E2E8F0"/>
-                </a:solidFill>
-                <a:latin typeface="Times New Roman"/>
-                <a:cs typeface="Times New Roman"/>
-                <a:ea typeface="Times New Roman"/>
-              </a:rPr>
-              <a:t>- Kuchli elektr maydoni ta'sirida elektronlar "kutilmaganda" o'tib bo'lmas oksid to'sig'idan teshib o'tib, zulfin ichiga tushib qoladi. Bu mo'jizaviy kvant hodisasi axborotni fleshkaga yozish imkonini beradi.</a:t>
+              <a:t>7 / 10</a:t>
             </a:r>
           </a:p>
         </p:txBody>
@@ -2373,14 +3475,14 @@
       </p:sp>
       <p:sp>
         <p:nvSpPr>
-          <p:cNvPr id="12" name="topbar"/>
-          <p:cNvSpPr/>
-          <p:nvPr/>
-        </p:nvSpPr>
-        <p:spPr>
-          <a:xfrm>
-            <a:off x="0" y="1051560"/>
-            <a:ext cx="12191695" cy="45720"/>
+          <p:cNvPr id="12" name="tbar"/>
+          <p:cNvSpPr/>
+          <p:nvPr/>
+        </p:nvSpPr>
+        <p:spPr>
+          <a:xfrm>
+            <a:off x="548640" y="301752"/>
+            <a:ext cx="128016" cy="566928"/>
           </a:xfrm>
           <a:prstGeom prst="rect">
             <a:avLst/>
@@ -2400,41 +3502,14 @@
       </p:sp>
       <p:sp>
         <p:nvSpPr>
-          <p:cNvPr id="13" name="tbar"/>
-          <p:cNvSpPr/>
-          <p:nvPr/>
-        </p:nvSpPr>
-        <p:spPr>
-          <a:xfrm>
-            <a:off x="548640" y="320040"/>
-            <a:ext cx="109728" cy="548640"/>
-          </a:xfrm>
-          <a:prstGeom prst="rect">
-            <a:avLst/>
-          </a:prstGeom>
-          <a:solidFill>
-            <a:srgbClr val="00C2D1"/>
-          </a:solidFill>
-          <a:ln>
-            <a:noFill/>
-          </a:ln>
-        </p:spPr>
-        <p:txBody>
-          <a:bodyPr/>
-          <a:lstStyle/>
-          <a:p/>
-        </p:txBody>
-      </p:sp>
-      <p:sp>
-        <p:nvSpPr>
-          <p:cNvPr id="14" name="title"/>
+          <p:cNvPr id="13" name="title"/>
           <p:cNvSpPr txBox="1"/>
           <p:nvPr/>
         </p:nvSpPr>
         <p:spPr>
           <a:xfrm>
-            <a:off x="822960" y="274320"/>
-            <a:ext cx="10789920" cy="822960"/>
+            <a:off x="868680" y="256032"/>
+            <a:ext cx="10789920" cy="713232"/>
           </a:xfrm>
           <a:prstGeom prst="rect">
             <a:avLst/>
@@ -2461,11 +3536,67 @@
           </a:p>
         </p:txBody>
       </p:sp>
+      <p:sp>
+        <p:nvSpPr>
+          <p:cNvPr id="14" name="topbar"/>
+          <p:cNvSpPr/>
+          <p:nvPr/>
+        </p:nvSpPr>
+        <p:spPr>
+          <a:xfrm>
+            <a:off x="548640" y="1024128"/>
+            <a:ext cx="11091672" cy="36576"/>
+          </a:xfrm>
+          <a:prstGeom prst="rect">
+            <a:avLst/>
+          </a:prstGeom>
+          <a:solidFill>
+            <a:srgbClr val="00C2D1"/>
+          </a:solidFill>
+          <a:ln>
+            <a:noFill/>
+          </a:ln>
+        </p:spPr>
+        <p:txBody>
+          <a:bodyPr/>
+          <a:lstStyle/>
+          <a:p/>
+        </p:txBody>
+      </p:sp>
+      <p:sp>
+        <p:nvSpPr>
+          <p:cNvPr id="15" name="imgpanel"/>
+          <p:cNvSpPr/>
+          <p:nvPr/>
+        </p:nvSpPr>
+        <p:spPr>
+          <a:xfrm>
+            <a:off x="7635240" y="1325880"/>
+            <a:ext cx="4005072" cy="4892040"/>
+          </a:xfrm>
+          <a:prstGeom prst="rect">
+            <a:avLst/>
+          </a:prstGeom>
+          <a:solidFill>
+            <a:srgbClr val="122A45"/>
+          </a:solidFill>
+          <a:ln w="12700">
+            <a:solidFill>
+              <a:srgbClr val="3B82F6"/>
+            </a:solidFill>
+          </a:ln>
+        </p:spPr>
+        <p:txBody>
+          <a:bodyPr/>
+          <a:lstStyle/>
+          <a:p/>
+        </p:txBody>
+      </p:sp>
       <p:pic>
         <p:nvPicPr>
-          <p:cNvPr id="15" name="img"/>
+          <p:cNvPr id="16" name="img"/>
           <p:cNvPicPr>
-            <a:picLocks noChangeAspect="0"/>
+            <a:picLocks noChangeAspect="1"/>
           </p:cNvPicPr>
           <p:nvPr/>
         </p:nvPicPr>
@@ -2477,8 +3608,8 @@
         </p:blipFill>
         <p:spPr>
           <a:xfrm>
-            <a:off x="7772400" y="1463040"/>
-            <a:ext cx="3931920" cy="4937760"/>
+            <a:off x="7799832" y="1933956"/>
+            <a:ext cx="3675888" cy="3675888"/>
           </a:xfrm>
           <a:prstGeom prst="rect">
             <a:avLst/>
@@ -2487,14 +3618,14 @@
       </p:pic>
       <p:sp>
         <p:nvSpPr>
-          <p:cNvPr id="16" name="panel"/>
-          <p:cNvSpPr/>
-          <p:nvPr/>
-        </p:nvSpPr>
-        <p:spPr>
-          <a:xfrm>
-            <a:off x="457200" y="1463040"/>
-            <a:ext cx="7040880" cy="4937760"/>
+          <p:cNvPr id="17" name="panel"/>
+          <p:cNvSpPr/>
+          <p:nvPr/>
+        </p:nvSpPr>
+        <p:spPr>
+          <a:xfrm>
+            <a:off x="457200" y="1325880"/>
+            <a:ext cx="6858000" cy="4892040"/>
           </a:xfrm>
           <a:prstGeom prst="rect">
             <a:avLst/>
@@ -2514,14 +3645,41 @@
       </p:sp>
       <p:sp>
         <p:nvSpPr>
-          <p:cNvPr id="17" name="body"/>
+          <p:cNvPr id="18" name="panelbar"/>
+          <p:cNvSpPr/>
+          <p:nvPr/>
+        </p:nvSpPr>
+        <p:spPr>
+          <a:xfrm>
+            <a:off x="457200" y="1325880"/>
+            <a:ext cx="73152" cy="4892040"/>
+          </a:xfrm>
+          <a:prstGeom prst="rect">
+            <a:avLst/>
+          </a:prstGeom>
+          <a:solidFill>
+            <a:srgbClr val="00C2D1"/>
+          </a:solidFill>
+          <a:ln>
+            <a:noFill/>
+          </a:ln>
+        </p:spPr>
+        <p:txBody>
+          <a:bodyPr/>
+          <a:lstStyle/>
+          <a:p/>
+        </p:txBody>
+      </p:sp>
+      <p:sp>
+        <p:nvSpPr>
+          <p:cNvPr id="19" name="body"/>
           <p:cNvSpPr txBox="1"/>
           <p:nvPr/>
         </p:nvSpPr>
         <p:spPr>
           <a:xfrm>
-            <a:off x="731520" y="1691640"/>
-            <a:ext cx="6492240" cy="4480560"/>
+            <a:off x="868680" y="1600200"/>
+            <a:ext cx="6126480" cy="4572000"/>
           </a:xfrm>
           <a:prstGeom prst="rect">
             <a:avLst/>
@@ -2535,11 +3693,77 @@
           <a:lstStyle/>
           <a:p>
             <a:pPr>
+              <a:spcBef>
+                <a:spcPts val="600"/>
+              </a:spcBef>
+              <a:spcAft>
+                <a:spcPts val="800"/>
+              </a:spcAft>
+            </a:pPr>
+            <a:r>
+              <a:rPr lang="uz-UZ" sz="1800" b="1" dirty="0">
+                <a:solidFill>
+                  <a:srgbClr val="00C2D1"/>
+                </a:solidFill>
+                <a:latin typeface="Times New Roman"/>
+                <a:cs typeface="Times New Roman"/>
+                <a:ea typeface="Times New Roman"/>
+              </a:rPr>
+              <a:t>Ma'lumotni o'chirish uchun fleshka zulfinga teskari kuchlanish beradi va elektronlarni kvant tunnellanish orqali yana tashqariga so'rib oladi.</a:t>
+            </a:r>
+          </a:p>
+          <a:p>
+            <a:pPr>
+              <a:spcBef>
+                <a:spcPts val="600"/>
+              </a:spcBef>
+              <a:spcAft>
+                <a:spcPts val="800"/>
+              </a:spcAft>
+            </a:pPr>
+            <a:r>
+              <a:rPr lang="uz-UZ" sz="1800" b="1" dirty="0">
+                <a:solidFill>
+                  <a:srgbClr val="00C2D1"/>
+                </a:solidFill>
+                <a:latin typeface="Times New Roman"/>
+                <a:cs typeface="Times New Roman"/>
+                <a:ea typeface="Times New Roman"/>
+              </a:rPr>
+              <a:t>Eskirish (Wear out):</a:t>
+            </a:r>
+          </a:p>
+          <a:p>
+            <a:pPr marL="256032" indent="0">
+              <a:spcBef>
+                <a:spcPts val="400"/>
+              </a:spcBef>
               <a:spcAft>
                 <a:spcPts val="1000"/>
               </a:spcAft>
             </a:pPr>
             <a:r>
+              <a:rPr lang="uz-UZ" sz="1600" dirty="0">
+                <a:solidFill>
+                  <a:srgbClr val="E2E8F0"/>
+                </a:solidFill>
+                <a:latin typeface="Times New Roman"/>
+                <a:cs typeface="Times New Roman"/>
+                <a:ea typeface="Times New Roman"/>
+              </a:rPr>
+              <a:t>- Har safar elektronlar oksid qatlamidan kuch bilan teshib o'tganda, bu izolyatsiya qatlami sekin-asta yemiriladi.</a:t>
+            </a:r>
+          </a:p>
+          <a:p>
+            <a:pPr>
+              <a:spcBef>
+                <a:spcPts val="600"/>
+              </a:spcBef>
+              <a:spcAft>
+                <a:spcPts val="800"/>
+              </a:spcAft>
+            </a:pPr>
+            <a:r>
               <a:rPr lang="uz-UZ" sz="1800" b="1" dirty="0">
                 <a:solidFill>
                   <a:srgbClr val="00C2D1"/>
@@ -2548,17 +3772,120 @@
                 <a:cs typeface="Times New Roman"/>
                 <a:ea typeface="Times New Roman"/>
               </a:rPr>
-              <a:t>Ma'lumotni o'chirish uchun fleshka zulfinga teskari kuchlanish beradi va elektronlarni kvant tunnellanish orqali yana tashqariga so'rib oladi.</a:t>
-            </a:r>
-          </a:p>
-          <a:p>
-            <a:pPr>
+              <a:t>Hayot sikli:</a:t>
+            </a:r>
+          </a:p>
+          <a:p>
+            <a:pPr marL="256032" indent="0">
+              <a:spcBef>
+                <a:spcPts val="400"/>
+              </a:spcBef>
               <a:spcAft>
                 <a:spcPts val="1000"/>
               </a:spcAft>
             </a:pPr>
             <a:r>
-              <a:rPr lang="uz-UZ" sz="1800" b="1" dirty="0">
+              <a:rPr lang="uz-UZ" sz="1600" dirty="0">
+                <a:solidFill>
+                  <a:srgbClr val="E2E8F0"/>
+                </a:solidFill>
+                <a:latin typeface="Times New Roman"/>
+                <a:cs typeface="Times New Roman"/>
+                <a:ea typeface="Times New Roman"/>
+              </a:rPr>
+              <a:t>- Shu sababli USB fleshkalarning ma'lum bir yozish/o'chirish tsikli bor (odatda 10,000 dan 100,000 martagacha). Bu limit tugagach, u axborot saqlay olmay qoladi.</a:t>
+            </a:r>
+          </a:p>
+        </p:txBody>
+      </p:sp>
+      <p:sp>
+        <p:nvSpPr>
+          <p:cNvPr id="20" name="footline"/>
+          <p:cNvSpPr/>
+          <p:nvPr/>
+        </p:nvSpPr>
+        <p:spPr>
+          <a:xfrm>
+            <a:off x="548640" y="6419088"/>
+            <a:ext cx="11091672" cy="10972"/>
+          </a:xfrm>
+          <a:prstGeom prst="rect">
+            <a:avLst/>
+          </a:prstGeom>
+          <a:solidFill>
+            <a:srgbClr val="122A45"/>
+          </a:solidFill>
+          <a:ln>
+            <a:noFill/>
+          </a:ln>
+        </p:spPr>
+        <p:txBody>
+          <a:bodyPr/>
+          <a:lstStyle/>
+          <a:p/>
+        </p:txBody>
+      </p:sp>
+      <p:sp>
+        <p:nvSpPr>
+          <p:cNvPr id="21" name="foot_l"/>
+          <p:cNvSpPr txBox="1"/>
+          <p:nvPr/>
+        </p:nvSpPr>
+        <p:spPr>
+          <a:xfrm>
+            <a:off x="548640" y="6455664"/>
+            <a:ext cx="8229600" cy="365760"/>
+          </a:xfrm>
+          <a:prstGeom prst="rect">
+            <a:avLst/>
+          </a:prstGeom>
+          <a:noFill/>
+        </p:spPr>
+        <p:txBody>
+          <a:bodyPr wrap="square" anchor="ctr">
+            <a:normAutofit/>
+          </a:bodyPr>
+          <a:lstStyle/>
+          <a:p>
+            <a:r>
+              <a:rPr lang="uz-UZ" sz="1400" dirty="0">
+                <a:solidFill>
+                  <a:srgbClr val="E2E8F0"/>
+                </a:solidFill>
+                <a:latin typeface="Times New Roman"/>
+                <a:cs typeface="Times New Roman"/>
+                <a:ea typeface="Times New Roman"/>
+              </a:rPr>
+              <a:t>Fleshkalar (USB) qanday ishlaydi?</a:t>
+            </a:r>
+          </a:p>
+        </p:txBody>
+      </p:sp>
+      <p:sp>
+        <p:nvSpPr>
+          <p:cNvPr id="22" name="foot_r"/>
+          <p:cNvSpPr txBox="1"/>
+          <p:nvPr/>
+        </p:nvSpPr>
+        <p:spPr>
+          <a:xfrm>
+            <a:off x="8961120" y="6455664"/>
+            <a:ext cx="2679192" cy="365760"/>
+          </a:xfrm>
+          <a:prstGeom prst="rect">
+            <a:avLst/>
+          </a:prstGeom>
+          <a:noFill/>
+        </p:spPr>
+        <p:txBody>
+          <a:bodyPr wrap="square" anchor="ctr">
+            <a:normAutofit/>
+          </a:bodyPr>
+          <a:lstStyle/>
+          <a:p>
+            <a:pPr algn="r"/>
+            <a:r>
+              <a:rPr lang="uz-UZ" sz="1400" b="1" dirty="0">
                 <a:solidFill>
                   <a:srgbClr val="00C2D1"/>
                 </a:solidFill>
@@ -2566,61 +3893,7 @@
                 <a:cs typeface="Times New Roman"/>
                 <a:ea typeface="Times New Roman"/>
               </a:rPr>
-              <a:t>Eskirish (Wear out):</a:t>
-            </a:r>
-          </a:p>
-          <a:p>
-            <a:pPr>
-              <a:spcAft>
-                <a:spcPts val="1000"/>
-              </a:spcAft>
-            </a:pPr>
-            <a:r>
-              <a:rPr lang="uz-UZ" sz="1600" dirty="0">
-                <a:solidFill>
-                  <a:srgbClr val="E2E8F0"/>
-                </a:solidFill>
-                <a:latin typeface="Times New Roman"/>
-                <a:cs typeface="Times New Roman"/>
-                <a:ea typeface="Times New Roman"/>
-              </a:rPr>
-              <a:t>- Har safar elektronlar oksid qatlamidan kuch bilan teshib o'tganda, bu izolyatsiya qatlami sekin-asta yemiriladi.</a:t>
-            </a:r>
-          </a:p>
-          <a:p>
-            <a:pPr>
-              <a:spcAft>
-                <a:spcPts val="1000"/>
-              </a:spcAft>
-            </a:pPr>
-            <a:r>
-              <a:rPr lang="uz-UZ" sz="1800" b="1" dirty="0">
-                <a:solidFill>
-                  <a:srgbClr val="00C2D1"/>
-                </a:solidFill>
-                <a:latin typeface="Times New Roman"/>
-                <a:cs typeface="Times New Roman"/>
-                <a:ea typeface="Times New Roman"/>
-              </a:rPr>
-              <a:t>Hayot sikli:</a:t>
-            </a:r>
-          </a:p>
-          <a:p>
-            <a:pPr>
-              <a:spcAft>
-                <a:spcPts val="1000"/>
-              </a:spcAft>
-            </a:pPr>
-            <a:r>
-              <a:rPr lang="uz-UZ" sz="1600" dirty="0">
-                <a:solidFill>
-                  <a:srgbClr val="E2E8F0"/>
-                </a:solidFill>
-                <a:latin typeface="Times New Roman"/>
-                <a:cs typeface="Times New Roman"/>
-                <a:ea typeface="Times New Roman"/>
-              </a:rPr>
-              <a:t>- Shu sababli USB fleshkalarning ma'lum bir yozish/o'chirish tsikli bor (odatda 10,000 dan 100,000 martagacha). Bu limit tugagach, u axborot saqlay olmay qoladi.</a:t>
+              <a:t>8 / 10</a:t>
             </a:r>
           </a:p>
         </p:txBody>
@@ -2679,14 +3952,14 @@
       </p:sp>
       <p:sp>
         <p:nvSpPr>
-          <p:cNvPr id="12" name="topbar"/>
-          <p:cNvSpPr/>
-          <p:nvPr/>
-        </p:nvSpPr>
-        <p:spPr>
-          <a:xfrm>
-            <a:off x="0" y="1051560"/>
-            <a:ext cx="12191695" cy="45720"/>
+          <p:cNvPr id="12" name="tbar"/>
+          <p:cNvSpPr/>
+          <p:nvPr/>
+        </p:nvSpPr>
+        <p:spPr>
+          <a:xfrm>
+            <a:off x="548640" y="301752"/>
+            <a:ext cx="128016" cy="566928"/>
           </a:xfrm>
           <a:prstGeom prst="rect">
             <a:avLst/>
@@ -2706,41 +3979,14 @@
       </p:sp>
       <p:sp>
         <p:nvSpPr>
-          <p:cNvPr id="13" name="tbar"/>
-          <p:cNvSpPr/>
-          <p:nvPr/>
-        </p:nvSpPr>
-        <p:spPr>
-          <a:xfrm>
-            <a:off x="548640" y="320040"/>
-            <a:ext cx="109728" cy="548640"/>
-          </a:xfrm>
-          <a:prstGeom prst="rect">
-            <a:avLst/>
-          </a:prstGeom>
-          <a:solidFill>
-            <a:srgbClr val="00C2D1"/>
-          </a:solidFill>
-          <a:ln>
-            <a:noFill/>
-          </a:ln>
-        </p:spPr>
-        <p:txBody>
-          <a:bodyPr/>
-          <a:lstStyle/>
-          <a:p/>
-        </p:txBody>
-      </p:sp>
-      <p:sp>
-        <p:nvSpPr>
-          <p:cNvPr id="14" name="title"/>
+          <p:cNvPr id="13" name="title"/>
           <p:cNvSpPr txBox="1"/>
           <p:nvPr/>
         </p:nvSpPr>
         <p:spPr>
           <a:xfrm>
-            <a:off x="822960" y="274320"/>
-            <a:ext cx="10789920" cy="822960"/>
+            <a:off x="868680" y="256032"/>
+            <a:ext cx="10789920" cy="713232"/>
           </a:xfrm>
           <a:prstGeom prst="rect">
             <a:avLst/>
@@ -2767,11 +4013,67 @@
           </a:p>
         </p:txBody>
       </p:sp>
+      <p:sp>
+        <p:nvSpPr>
+          <p:cNvPr id="14" name="topbar"/>
+          <p:cNvSpPr/>
+          <p:nvPr/>
+        </p:nvSpPr>
+        <p:spPr>
+          <a:xfrm>
+            <a:off x="548640" y="1024128"/>
+            <a:ext cx="11091672" cy="36576"/>
+          </a:xfrm>
+          <a:prstGeom prst="rect">
+            <a:avLst/>
+          </a:prstGeom>
+          <a:solidFill>
+            <a:srgbClr val="00C2D1"/>
+          </a:solidFill>
+          <a:ln>
+            <a:noFill/>
+          </a:ln>
+        </p:spPr>
+        <p:txBody>
+          <a:bodyPr/>
+          <a:lstStyle/>
+          <a:p/>
+        </p:txBody>
+      </p:sp>
+      <p:sp>
+        <p:nvSpPr>
+          <p:cNvPr id="15" name="imgpanel"/>
+          <p:cNvSpPr/>
+          <p:nvPr/>
+        </p:nvSpPr>
+        <p:spPr>
+          <a:xfrm>
+            <a:off x="7635240" y="1325880"/>
+            <a:ext cx="4005072" cy="4892040"/>
+          </a:xfrm>
+          <a:prstGeom prst="rect">
+            <a:avLst/>
+          </a:prstGeom>
+          <a:solidFill>
+            <a:srgbClr val="122A45"/>
+          </a:solidFill>
+          <a:ln w="12700">
+            <a:solidFill>
+              <a:srgbClr val="3B82F6"/>
+            </a:solidFill>
+          </a:ln>
+        </p:spPr>
+        <p:txBody>
+          <a:bodyPr/>
+          <a:lstStyle/>
+          <a:p/>
+        </p:txBody>
+      </p:sp>
       <p:pic>
         <p:nvPicPr>
-          <p:cNvPr id="15" name="img"/>
+          <p:cNvPr id="16" name="img"/>
           <p:cNvPicPr>
-            <a:picLocks noChangeAspect="0"/>
+            <a:picLocks noChangeAspect="1"/>
           </p:cNvPicPr>
           <p:nvPr/>
         </p:nvPicPr>
@@ -2783,8 +4085,8 @@
         </p:blipFill>
         <p:spPr>
           <a:xfrm>
-            <a:off x="7772400" y="1463040"/>
-            <a:ext cx="3931920" cy="4937760"/>
+            <a:off x="7799832" y="1933956"/>
+            <a:ext cx="3675888" cy="3675888"/>
           </a:xfrm>
           <a:prstGeom prst="rect">
             <a:avLst/>
@@ -2793,14 +4095,14 @@
       </p:pic>
       <p:sp>
         <p:nvSpPr>
-          <p:cNvPr id="16" name="panel"/>
-          <p:cNvSpPr/>
-          <p:nvPr/>
-        </p:nvSpPr>
-        <p:spPr>
-          <a:xfrm>
-            <a:off x="457200" y="1463040"/>
-            <a:ext cx="7040880" cy="4937760"/>
+          <p:cNvPr id="17" name="panel"/>
+          <p:cNvSpPr/>
+          <p:nvPr/>
+        </p:nvSpPr>
+        <p:spPr>
+          <a:xfrm>
+            <a:off x="457200" y="1325880"/>
+            <a:ext cx="6858000" cy="4892040"/>
           </a:xfrm>
           <a:prstGeom prst="rect">
             <a:avLst/>
@@ -2820,14 +4122,41 @@
       </p:sp>
       <p:sp>
         <p:nvSpPr>
-          <p:cNvPr id="17" name="body"/>
+          <p:cNvPr id="18" name="panelbar"/>
+          <p:cNvSpPr/>
+          <p:nvPr/>
+        </p:nvSpPr>
+        <p:spPr>
+          <a:xfrm>
+            <a:off x="457200" y="1325880"/>
+            <a:ext cx="73152" cy="4892040"/>
+          </a:xfrm>
+          <a:prstGeom prst="rect">
+            <a:avLst/>
+          </a:prstGeom>
+          <a:solidFill>
+            <a:srgbClr val="00C2D1"/>
+          </a:solidFill>
+          <a:ln>
+            <a:noFill/>
+          </a:ln>
+        </p:spPr>
+        <p:txBody>
+          <a:bodyPr/>
+          <a:lstStyle/>
+          <a:p/>
+        </p:txBody>
+      </p:sp>
+      <p:sp>
+        <p:nvSpPr>
+          <p:cNvPr id="19" name="body"/>
           <p:cNvSpPr txBox="1"/>
           <p:nvPr/>
         </p:nvSpPr>
         <p:spPr>
           <a:xfrm>
-            <a:off x="731520" y="1691640"/>
-            <a:ext cx="6492240" cy="4480560"/>
+            <a:off x="868680" y="1600200"/>
+            <a:ext cx="6126480" cy="4572000"/>
           </a:xfrm>
           <a:prstGeom prst="rect">
             <a:avLst/>
@@ -2841,8 +4170,11 @@
           <a:lstStyle/>
           <a:p>
             <a:pPr>
+              <a:spcBef>
+                <a:spcPts val="600"/>
+              </a:spcBef>
               <a:spcAft>
-                <a:spcPts val="1000"/>
+                <a:spcPts val="800"/>
               </a:spcAft>
             </a:pPr>
             <a:r>
@@ -2859,8 +4191,11 @@
           </a:p>
           <a:p>
             <a:pPr>
+              <a:spcBef>
+                <a:spcPts val="600"/>
+              </a:spcBef>
               <a:spcAft>
-                <a:spcPts val="1000"/>
+                <a:spcPts val="800"/>
               </a:spcAft>
             </a:pPr>
             <a:r>
@@ -2873,6 +4208,106 @@
                 <a:ea typeface="Times New Roman"/>
               </a:rPr>
               <a:t>Kvant tunnellanish effekti kabi murakkab fizik qonuniyatlar insoniyatga ma'lumotlarni harakatlanuvchi mexanizmlarsiz, sof elektr zaryadlari ko'rinishida saqlash va bugungi tezkor axborot tizimlarini yaratish imkonini berdi.</a:t>
+            </a:r>
+          </a:p>
+        </p:txBody>
+      </p:sp>
+      <p:sp>
+        <p:nvSpPr>
+          <p:cNvPr id="20" name="footline"/>
+          <p:cNvSpPr/>
+          <p:nvPr/>
+        </p:nvSpPr>
+        <p:spPr>
+          <a:xfrm>
+            <a:off x="548640" y="6419088"/>
+            <a:ext cx="11091672" cy="10972"/>
+          </a:xfrm>
+          <a:prstGeom prst="rect">
+            <a:avLst/>
+          </a:prstGeom>
+          <a:solidFill>
+            <a:srgbClr val="122A45"/>
+          </a:solidFill>
+          <a:ln>
+            <a:noFill/>
+          </a:ln>
+        </p:spPr>
+        <p:txBody>
+          <a:bodyPr/>
+          <a:lstStyle/>
+          <a:p/>
+        </p:txBody>
+      </p:sp>
+      <p:sp>
+        <p:nvSpPr>
+          <p:cNvPr id="21" name="foot_l"/>
+          <p:cNvSpPr txBox="1"/>
+          <p:nvPr/>
+        </p:nvSpPr>
+        <p:spPr>
+          <a:xfrm>
+            <a:off x="548640" y="6455664"/>
+            <a:ext cx="8229600" cy="365760"/>
+          </a:xfrm>
+          <a:prstGeom prst="rect">
+            <a:avLst/>
+          </a:prstGeom>
+          <a:noFill/>
+        </p:spPr>
+        <p:txBody>
+          <a:bodyPr wrap="square" anchor="ctr">
+            <a:normAutofit/>
+          </a:bodyPr>
+          <a:lstStyle/>
+          <a:p>
+            <a:r>
+              <a:rPr lang="uz-UZ" sz="1400" dirty="0">
+                <a:solidFill>
+                  <a:srgbClr val="E2E8F0"/>
+                </a:solidFill>
+                <a:latin typeface="Times New Roman"/>
+                <a:cs typeface="Times New Roman"/>
+                <a:ea typeface="Times New Roman"/>
+              </a:rPr>
+              <a:t>Fleshkalar (USB) qanday ishlaydi?</a:t>
+            </a:r>
+          </a:p>
+        </p:txBody>
+      </p:sp>
+      <p:sp>
+        <p:nvSpPr>
+          <p:cNvPr id="22" name="foot_r"/>
+          <p:cNvSpPr txBox="1"/>
+          <p:nvPr/>
+        </p:nvSpPr>
+        <p:spPr>
+          <a:xfrm>
+            <a:off x="8961120" y="6455664"/>
+            <a:ext cx="2679192" cy="365760"/>
+          </a:xfrm>
+          <a:prstGeom prst="rect">
+            <a:avLst/>
+          </a:prstGeom>
+          <a:noFill/>
+        </p:spPr>
+        <p:txBody>
+          <a:bodyPr wrap="square" anchor="ctr">
+            <a:normAutofit/>
+          </a:bodyPr>
+          <a:lstStyle/>
+          <a:p>
+            <a:pPr algn="r"/>
+            <a:r>
+              <a:rPr lang="uz-UZ" sz="1400" b="1" dirty="0">
+                <a:solidFill>
+                  <a:srgbClr val="00C2D1"/>
+                </a:solidFill>
+                <a:latin typeface="Times New Roman"/>
+                <a:cs typeface="Times New Roman"/>
+                <a:ea typeface="Times New Roman"/>
+              </a:rPr>
+              <a:t>9 / 10</a:t>
             </a:r>
           </a:p>
         </p:txBody>

</xml_diff>